<commit_message>
Complete PROJECT-021: Credit Card Fraud Detection Suite (Port 5021, Balanced RF + GBM + Neural MLP, 10k dataset, SQLite DB, 31/31 tests, 8 UI screenshots, 15 slides PPTX, 65-para DOCX + 8 MD suite, exact 180s walkthrough video)
</commit_message>
<xml_diff>
--- a/project_21_credit_card_fraud/presentations/project_presentation.pptx
+++ b/project_21_credit_card_fraud/presentations/project_presentation.pptx
@@ -13,6 +13,13 @@
     <p:sldId id="261" r:id="rId12"/>
     <p:sldId id="262" r:id="rId13"/>
     <p:sldId id="263" r:id="rId14"/>
+    <p:sldId id="264" r:id="rId15"/>
+    <p:sldId id="265" r:id="rId16"/>
+    <p:sldId id="266" r:id="rId17"/>
+    <p:sldId id="267" r:id="rId18"/>
+    <p:sldId id="268" r:id="rId19"/>
+    <p:sldId id="269" r:id="rId20"/>
+    <p:sldId id="270" r:id="rId21"/>
   </p:sldIdLst>
   <p:sldSz cx="12191695" cy="6858000" type="screen4x3"/>
   <p:notesSz cx="6858000" cy="9144000"/>
@@ -3110,7 +3117,7 @@
             <a:avLst/>
           </a:prstGeom>
           <a:solidFill>
-            <a:srgbClr val="0F172A"/>
+            <a:srgbClr val="060913"/>
           </a:solidFill>
           <a:ln>
             <a:noFill/>
@@ -3146,8 +3153,8 @@
         </p:nvSpPr>
         <p:spPr>
           <a:xfrm>
-            <a:off x="1097280" y="1645920"/>
-            <a:ext cx="10058400" cy="3474720"/>
+            <a:off x="914400" y="1645920"/>
+            <a:ext cx="10362895" cy="3657600"/>
           </a:xfrm>
           <a:prstGeom prst="rect">
             <a:avLst/>
@@ -3161,44 +3168,1630 @@
           <a:lstStyle/>
           <a:p>
             <a:pPr>
-              <a:defRPr sz="1400" b="1">
+              <a:defRPr sz="1300" b="1">
+                <a:solidFill>
+                  <a:srgbClr val="10B981"/>
+                </a:solidFill>
+              </a:defRPr>
+            </a:pPr>
+            <a:r>
+              <a:t>PROJECT-021: CAPSTONE DEFENSE</a:t>
+            </a:r>
+          </a:p>
+          <a:p>
+            <a:pPr>
+              <a:defRPr sz="2800" b="1">
+                <a:solidFill>
+                  <a:srgbClr val="F8FAFC"/>
+                </a:solidFill>
+              </a:defRPr>
+            </a:pPr>
+            <a:r>
+              <a:t>Credit Card Fraud Detection using Machine Learning Algorithms</a:t>
+            </a:r>
+          </a:p>
+          <a:p>
+            <a:br/>
+            <a:pPr>
+              <a:defRPr sz="1300">
                 <a:solidFill>
                   <a:srgbClr val="38BDF8"/>
                 </a:solidFill>
               </a:defRPr>
             </a:pPr>
             <a:r>
-              <a:t>PROJECT 21 OF 55  •  RESEARCH &amp; IMPLEMENTATION DECK</a:t>
-            </a:r>
-          </a:p>
-          <a:p>
-            <a:pPr>
-              <a:spcBef>
-                <a:spcPts val="1400"/>
-              </a:spcBef>
-              <a:defRPr sz="3200" b="1">
-                <a:solidFill>
-                  <a:srgbClr val="FFFFFF"/>
-                </a:solidFill>
-              </a:defRPr>
-            </a:pPr>
-            <a:r>
-              <a:t>Credit Card Fraud Detection using Machine Learning Algorithms</a:t>
-            </a:r>
-          </a:p>
-          <a:p>
-            <a:pPr>
-              <a:spcBef>
-                <a:spcPts val="1200"/>
-              </a:spcBef>
-              <a:defRPr sz="1600">
-                <a:solidFill>
-                  <a:srgbClr val="CBD5E1"/>
-                </a:solidFill>
-              </a:defRPr>
-            </a:pPr>
-            <a:r>
-              <a:t>Enterprise-Grade AI Architecture, Machine Learning Pipeline &amp; Deployment Framework</a:t>
+              <a:t>Multi-Model Ensemble (Random Forest + Gradient Boosting + Neural MLP) • SHAP-Style Directional Attributions</a:t>
+            </a:r>
+          </a:p>
+          <a:p>
+            <a:pPr>
+              <a:defRPr sz="1200">
+                <a:solidFill>
+                  <a:srgbClr val="94A3B8"/>
+                </a:solidFill>
+              </a:defRPr>
+            </a:pPr>
+            <a:r>
+              <a:t>Production Port: 5021 • 31 Automated Tests (100% Pass) • 10,000 Transaction Kaggle Schema • SQLite Persistent Ledger</a:t>
+            </a:r>
+          </a:p>
+        </p:txBody>
+      </p:sp>
+    </p:spTree>
+  </p:cSld>
+  <p:clrMapOvr>
+    <a:masterClrMapping/>
+  </p:clrMapOvr>
+</p:sld>
+</file>
+
+<file path=ppt/slides/slide10.xml><?xml version="1.0" encoding="utf-8"?>
+<p:sld xmlns:a="http://schemas.openxmlformats.org/drawingml/2006/main" xmlns:p="http://schemas.openxmlformats.org/presentationml/2006/main" xmlns:r="http://schemas.openxmlformats.org/officeDocument/2006/relationships">
+  <p:cSld>
+    <p:spTree>
+      <p:nvGrpSpPr>
+        <p:cNvPr id="1" name=""/>
+        <p:cNvGrpSpPr/>
+        <p:nvPr/>
+      </p:nvGrpSpPr>
+      <p:grpSpPr/>
+      <p:sp>
+        <p:nvSpPr>
+          <p:cNvPr id="2" name="Rectangle 1"/>
+          <p:cNvSpPr/>
+          <p:nvPr/>
+        </p:nvSpPr>
+        <p:spPr>
+          <a:xfrm>
+            <a:off x="0" y="0"/>
+            <a:ext cx="12191695" cy="6858000"/>
+          </a:xfrm>
+          <a:prstGeom prst="rect">
+            <a:avLst/>
+          </a:prstGeom>
+          <a:solidFill>
+            <a:srgbClr val="060913"/>
+          </a:solidFill>
+          <a:ln>
+            <a:noFill/>
+          </a:ln>
+        </p:spPr>
+        <p:style>
+          <a:lnRef idx="1">
+            <a:schemeClr val="accent1"/>
+          </a:lnRef>
+          <a:fillRef idx="3">
+            <a:schemeClr val="accent1"/>
+          </a:fillRef>
+          <a:effectRef idx="2">
+            <a:schemeClr val="accent1"/>
+          </a:effectRef>
+          <a:fontRef idx="minor">
+            <a:schemeClr val="lt1"/>
+          </a:fontRef>
+        </p:style>
+        <p:txBody>
+          <a:bodyPr rtlCol="0" anchor="ctr"/>
+          <a:lstStyle/>
+          <a:p>
+            <a:pPr algn="ctr"/>
+          </a:p>
+        </p:txBody>
+      </p:sp>
+      <p:sp>
+        <p:nvSpPr>
+          <p:cNvPr id="3" name="TextBox 2"/>
+          <p:cNvSpPr txBox="1"/>
+          <p:nvPr/>
+        </p:nvSpPr>
+        <p:spPr>
+          <a:xfrm>
+            <a:off x="731520" y="365760"/>
+            <a:ext cx="10728655" cy="1005840"/>
+          </a:xfrm>
+          <a:prstGeom prst="rect">
+            <a:avLst/>
+          </a:prstGeom>
+          <a:noFill/>
+        </p:spPr>
+        <p:txBody>
+          <a:bodyPr wrap="square">
+            <a:spAutoFit/>
+          </a:bodyPr>
+          <a:lstStyle/>
+          <a:p>
+            <a:pPr>
+              <a:defRPr sz="1100" b="1">
+                <a:solidFill>
+                  <a:srgbClr val="F59E0B"/>
+                </a:solidFill>
+              </a:defRPr>
+            </a:pPr>
+            <a:r>
+              <a:t>FINTECH MACHINE LEARNING &amp; CYBER RISK • PROJECT-021</a:t>
+            </a:r>
+          </a:p>
+          <a:p>
+            <a:pPr>
+              <a:defRPr sz="2200" b="1">
+                <a:solidFill>
+                  <a:srgbClr val="F8FAFC"/>
+                </a:solidFill>
+              </a:defRPr>
+            </a:pPr>
+            <a:r>
+              <a:t>High-Throughput Batch Evaluation &amp; Mass Stream Processing</a:t>
+            </a:r>
+          </a:p>
+        </p:txBody>
+      </p:sp>
+      <p:pic>
+        <p:nvPicPr>
+          <p:cNvPr id="4" name="Picture 3" descr="06_batch_evaluation_matrix.png"/>
+          <p:cNvPicPr>
+            <a:picLocks noChangeAspect="1"/>
+          </p:cNvPicPr>
+          <p:nvPr/>
+        </p:nvPicPr>
+        <p:blipFill>
+          <a:blip r:embed="rId2"/>
+          <a:stretch>
+            <a:fillRect/>
+          </a:stretch>
+        </p:blipFill>
+        <p:spPr>
+          <a:xfrm>
+            <a:off x="731520" y="1463040"/>
+            <a:ext cx="6858000" cy="4754880"/>
+          </a:xfrm>
+          <a:prstGeom prst="rect">
+            <a:avLst/>
+          </a:prstGeom>
+        </p:spPr>
+      </p:pic>
+      <p:sp>
+        <p:nvSpPr>
+          <p:cNvPr id="5" name="TextBox 4"/>
+          <p:cNvSpPr txBox="1"/>
+          <p:nvPr/>
+        </p:nvSpPr>
+        <p:spPr>
+          <a:xfrm>
+            <a:off x="7863840" y="1463040"/>
+            <a:ext cx="3657600" cy="4754880"/>
+          </a:xfrm>
+          <a:prstGeom prst="rect">
+            <a:avLst/>
+          </a:prstGeom>
+          <a:noFill/>
+        </p:spPr>
+        <p:txBody>
+          <a:bodyPr wrap="square">
+            <a:spAutoFit/>
+          </a:bodyPr>
+          <a:lstStyle/>
+          <a:p>
+            <a:pPr>
+              <a:defRPr b="1" sz="1500">
+                <a:solidFill>
+                  <a:srgbClr val="38BDF8"/>
+                </a:solidFill>
+              </a:defRPr>
+            </a:pPr>
+            <a:r>
+              <a:t>Batch Processing</a:t>
+            </a:r>
+          </a:p>
+          <a:p>
+            <a:pPr>
+              <a:defRPr sz="1100">
+                <a:solidFill>
+                  <a:srgbClr val="94A3B8"/>
+                </a:solidFill>
+              </a:defRPr>
+            </a:pPr>
+            <a:r>
+              <a:t>✔ Evaluates high-volume transaction arrays in single pass</a:t>
+            </a:r>
+          </a:p>
+          <a:p>
+            <a:pPr>
+              <a:defRPr sz="1100">
+                <a:solidFill>
+                  <a:srgbClr val="94A3B8"/>
+                </a:solidFill>
+              </a:defRPr>
+            </a:pPr>
+            <a:r>
+              <a:t>✔ Animated progress bar displaying completion status</a:t>
+            </a:r>
+          </a:p>
+          <a:p>
+            <a:pPr>
+              <a:defRPr sz="1100">
+                <a:solidFill>
+                  <a:srgbClr val="94A3B8"/>
+                </a:solidFill>
+              </a:defRPr>
+            </a:pPr>
+            <a:r>
+              <a:t>✔ Instant summary: Flagged count, Clean count, Total volume</a:t>
+            </a:r>
+          </a:p>
+          <a:p>
+            <a:pPr>
+              <a:defRPr sz="1100">
+                <a:solidFill>
+                  <a:srgbClr val="94A3B8"/>
+                </a:solidFill>
+              </a:defRPr>
+            </a:pPr>
+            <a:r>
+              <a:t>✔ Color-coded risk distribution and per-transaction breakdown</a:t>
+            </a:r>
+          </a:p>
+          <a:p>
+            <a:pPr>
+              <a:defRPr sz="1100">
+                <a:solidFill>
+                  <a:srgbClr val="94A3B8"/>
+                </a:solidFill>
+              </a:defRPr>
+            </a:pPr>
+            <a:r>
+              <a:t>✔ Bulk CSV / JSON export for compliance auditing</a:t>
+            </a:r>
+          </a:p>
+        </p:txBody>
+      </p:sp>
+    </p:spTree>
+  </p:cSld>
+  <p:clrMapOvr>
+    <a:masterClrMapping/>
+  </p:clrMapOvr>
+</p:sld>
+</file>
+
+<file path=ppt/slides/slide11.xml><?xml version="1.0" encoding="utf-8"?>
+<p:sld xmlns:a="http://schemas.openxmlformats.org/drawingml/2006/main" xmlns:p="http://schemas.openxmlformats.org/presentationml/2006/main" xmlns:r="http://schemas.openxmlformats.org/officeDocument/2006/relationships">
+  <p:cSld>
+    <p:spTree>
+      <p:nvGrpSpPr>
+        <p:cNvPr id="1" name=""/>
+        <p:cNvGrpSpPr/>
+        <p:nvPr/>
+      </p:nvGrpSpPr>
+      <p:grpSpPr/>
+      <p:sp>
+        <p:nvSpPr>
+          <p:cNvPr id="2" name="Rectangle 1"/>
+          <p:cNvSpPr/>
+          <p:nvPr/>
+        </p:nvSpPr>
+        <p:spPr>
+          <a:xfrm>
+            <a:off x="0" y="0"/>
+            <a:ext cx="12191695" cy="6858000"/>
+          </a:xfrm>
+          <a:prstGeom prst="rect">
+            <a:avLst/>
+          </a:prstGeom>
+          <a:solidFill>
+            <a:srgbClr val="060913"/>
+          </a:solidFill>
+          <a:ln>
+            <a:noFill/>
+          </a:ln>
+        </p:spPr>
+        <p:style>
+          <a:lnRef idx="1">
+            <a:schemeClr val="accent1"/>
+          </a:lnRef>
+          <a:fillRef idx="3">
+            <a:schemeClr val="accent1"/>
+          </a:fillRef>
+          <a:effectRef idx="2">
+            <a:schemeClr val="accent1"/>
+          </a:effectRef>
+          <a:fontRef idx="minor">
+            <a:schemeClr val="lt1"/>
+          </a:fontRef>
+        </p:style>
+        <p:txBody>
+          <a:bodyPr rtlCol="0" anchor="ctr"/>
+          <a:lstStyle/>
+          <a:p>
+            <a:pPr algn="ctr"/>
+          </a:p>
+        </p:txBody>
+      </p:sp>
+      <p:sp>
+        <p:nvSpPr>
+          <p:cNvPr id="3" name="TextBox 2"/>
+          <p:cNvSpPr txBox="1"/>
+          <p:nvPr/>
+        </p:nvSpPr>
+        <p:spPr>
+          <a:xfrm>
+            <a:off x="731520" y="365760"/>
+            <a:ext cx="10728655" cy="1005840"/>
+          </a:xfrm>
+          <a:prstGeom prst="rect">
+            <a:avLst/>
+          </a:prstGeom>
+          <a:noFill/>
+        </p:spPr>
+        <p:txBody>
+          <a:bodyPr wrap="square">
+            <a:spAutoFit/>
+          </a:bodyPr>
+          <a:lstStyle/>
+          <a:p>
+            <a:pPr>
+              <a:defRPr sz="1100" b="1">
+                <a:solidFill>
+                  <a:srgbClr val="F59E0B"/>
+                </a:solidFill>
+              </a:defRPr>
+            </a:pPr>
+            <a:r>
+              <a:t>FINTECH MACHINE LEARNING &amp; CYBER RISK • PROJECT-021</a:t>
+            </a:r>
+          </a:p>
+          <a:p>
+            <a:pPr>
+              <a:defRPr sz="2200" b="1">
+                <a:solidFill>
+                  <a:srgbClr val="F8FAFC"/>
+                </a:solidFill>
+              </a:defRPr>
+            </a:pPr>
+            <a:r>
+              <a:t>Card Sanctions, Risk Interlocks &amp; Blacklist Ledger</a:t>
+            </a:r>
+          </a:p>
+        </p:txBody>
+      </p:sp>
+      <p:pic>
+        <p:nvPicPr>
+          <p:cNvPr id="4" name="Picture 3" descr="07_card_sanctions_blacklist_ledger.png"/>
+          <p:cNvPicPr>
+            <a:picLocks noChangeAspect="1"/>
+          </p:cNvPicPr>
+          <p:nvPr/>
+        </p:nvPicPr>
+        <p:blipFill>
+          <a:blip r:embed="rId2"/>
+          <a:stretch>
+            <a:fillRect/>
+          </a:stretch>
+        </p:blipFill>
+        <p:spPr>
+          <a:xfrm>
+            <a:off x="731520" y="1463040"/>
+            <a:ext cx="6858000" cy="4754880"/>
+          </a:xfrm>
+          <a:prstGeom prst="rect">
+            <a:avLst/>
+          </a:prstGeom>
+        </p:spPr>
+      </p:pic>
+      <p:sp>
+        <p:nvSpPr>
+          <p:cNvPr id="5" name="TextBox 4"/>
+          <p:cNvSpPr txBox="1"/>
+          <p:nvPr/>
+        </p:nvSpPr>
+        <p:spPr>
+          <a:xfrm>
+            <a:off x="7863840" y="1463040"/>
+            <a:ext cx="3657600" cy="4754880"/>
+          </a:xfrm>
+          <a:prstGeom prst="rect">
+            <a:avLst/>
+          </a:prstGeom>
+          <a:noFill/>
+        </p:spPr>
+        <p:txBody>
+          <a:bodyPr wrap="square">
+            <a:spAutoFit/>
+          </a:bodyPr>
+          <a:lstStyle/>
+          <a:p>
+            <a:pPr>
+              <a:defRPr b="1" sz="1500">
+                <a:solidFill>
+                  <a:srgbClr val="F43F5E"/>
+                </a:solidFill>
+              </a:defRPr>
+            </a:pPr>
+            <a:r>
+              <a:t>Sanctions Engine</a:t>
+            </a:r>
+          </a:p>
+          <a:p>
+            <a:pPr>
+              <a:defRPr sz="1100">
+                <a:solidFill>
+                  <a:srgbClr val="F8FAFC"/>
+                </a:solidFill>
+              </a:defRPr>
+            </a:pPr>
+            <a:r>
+              <a:t>• Real-time card blacklist table persisted in SQLite</a:t>
+            </a:r>
+          </a:p>
+          <a:p>
+            <a:pPr>
+              <a:defRPr sz="1100">
+                <a:solidFill>
+                  <a:srgbClr val="F8FAFC"/>
+                </a:solidFill>
+              </a:defRPr>
+            </a:pPr>
+            <a:r>
+              <a:t>• Automated blacklisting on CRITICAL risk triggers</a:t>
+            </a:r>
+          </a:p>
+          <a:p>
+            <a:pPr>
+              <a:defRPr sz="1100">
+                <a:solidFill>
+                  <a:srgbClr val="F8FAFC"/>
+                </a:solidFill>
+              </a:defRPr>
+            </a:pPr>
+            <a:r>
+              <a:t>• Manual card freeze / unfreeze operator overrides</a:t>
+            </a:r>
+          </a:p>
+          <a:p>
+            <a:pPr>
+              <a:defRPr sz="1100">
+                <a:solidFill>
+                  <a:srgbClr val="F8FAFC"/>
+                </a:solidFill>
+              </a:defRPr>
+            </a:pPr>
+            <a:r>
+              <a:t>• Subsequent transactions from blocked cards auto-declined</a:t>
+            </a:r>
+          </a:p>
+          <a:p>
+            <a:pPr>
+              <a:defRPr sz="1100">
+                <a:solidFill>
+                  <a:srgbClr val="F8FAFC"/>
+                </a:solidFill>
+              </a:defRPr>
+            </a:pPr>
+            <a:r>
+              <a:t>• Full audit trail logging operator ID and sanction reasons</a:t>
+            </a:r>
+          </a:p>
+        </p:txBody>
+      </p:sp>
+    </p:spTree>
+  </p:cSld>
+  <p:clrMapOvr>
+    <a:masterClrMapping/>
+  </p:clrMapOvr>
+</p:sld>
+</file>
+
+<file path=ppt/slides/slide12.xml><?xml version="1.0" encoding="utf-8"?>
+<p:sld xmlns:a="http://schemas.openxmlformats.org/drawingml/2006/main" xmlns:p="http://schemas.openxmlformats.org/presentationml/2006/main" xmlns:r="http://schemas.openxmlformats.org/officeDocument/2006/relationships">
+  <p:cSld>
+    <p:spTree>
+      <p:nvGrpSpPr>
+        <p:cNvPr id="1" name=""/>
+        <p:cNvGrpSpPr/>
+        <p:nvPr/>
+      </p:nvGrpSpPr>
+      <p:grpSpPr/>
+      <p:sp>
+        <p:nvSpPr>
+          <p:cNvPr id="2" name="Rectangle 1"/>
+          <p:cNvSpPr/>
+          <p:nvPr/>
+        </p:nvSpPr>
+        <p:spPr>
+          <a:xfrm>
+            <a:off x="0" y="0"/>
+            <a:ext cx="12191695" cy="6858000"/>
+          </a:xfrm>
+          <a:prstGeom prst="rect">
+            <a:avLst/>
+          </a:prstGeom>
+          <a:solidFill>
+            <a:srgbClr val="060913"/>
+          </a:solidFill>
+          <a:ln>
+            <a:noFill/>
+          </a:ln>
+        </p:spPr>
+        <p:style>
+          <a:lnRef idx="1">
+            <a:schemeClr val="accent1"/>
+          </a:lnRef>
+          <a:fillRef idx="3">
+            <a:schemeClr val="accent1"/>
+          </a:fillRef>
+          <a:effectRef idx="2">
+            <a:schemeClr val="accent1"/>
+          </a:effectRef>
+          <a:fontRef idx="minor">
+            <a:schemeClr val="lt1"/>
+          </a:fontRef>
+        </p:style>
+        <p:txBody>
+          <a:bodyPr rtlCol="0" anchor="ctr"/>
+          <a:lstStyle/>
+          <a:p>
+            <a:pPr algn="ctr"/>
+          </a:p>
+        </p:txBody>
+      </p:sp>
+      <p:sp>
+        <p:nvSpPr>
+          <p:cNvPr id="3" name="TextBox 2"/>
+          <p:cNvSpPr txBox="1"/>
+          <p:nvPr/>
+        </p:nvSpPr>
+        <p:spPr>
+          <a:xfrm>
+            <a:off x="731520" y="365760"/>
+            <a:ext cx="10728655" cy="1005840"/>
+          </a:xfrm>
+          <a:prstGeom prst="rect">
+            <a:avLst/>
+          </a:prstGeom>
+          <a:noFill/>
+        </p:spPr>
+        <p:txBody>
+          <a:bodyPr wrap="square">
+            <a:spAutoFit/>
+          </a:bodyPr>
+          <a:lstStyle/>
+          <a:p>
+            <a:pPr>
+              <a:defRPr sz="1100" b="1">
+                <a:solidFill>
+                  <a:srgbClr val="F59E0B"/>
+                </a:solidFill>
+              </a:defRPr>
+            </a:pPr>
+            <a:r>
+              <a:t>FINTECH MACHINE LEARNING &amp; CYBER RISK • PROJECT-021</a:t>
+            </a:r>
+          </a:p>
+          <a:p>
+            <a:pPr>
+              <a:defRPr sz="2200" b="1">
+                <a:solidFill>
+                  <a:srgbClr val="F8FAFC"/>
+                </a:solidFill>
+              </a:defRPr>
+            </a:pPr>
+            <a:r>
+              <a:t>Relational SQLite Storage &amp; Forensic Audit Ledger</a:t>
+            </a:r>
+          </a:p>
+        </p:txBody>
+      </p:sp>
+      <p:pic>
+        <p:nvPicPr>
+          <p:cNvPr id="4" name="Picture 3" descr="08_sqlite_forensic_audit_dossier.png"/>
+          <p:cNvPicPr>
+            <a:picLocks noChangeAspect="1"/>
+          </p:cNvPicPr>
+          <p:nvPr/>
+        </p:nvPicPr>
+        <p:blipFill>
+          <a:blip r:embed="rId2"/>
+          <a:stretch>
+            <a:fillRect/>
+          </a:stretch>
+        </p:blipFill>
+        <p:spPr>
+          <a:xfrm>
+            <a:off x="731520" y="1463040"/>
+            <a:ext cx="6858000" cy="4754880"/>
+          </a:xfrm>
+          <a:prstGeom prst="rect">
+            <a:avLst/>
+          </a:prstGeom>
+        </p:spPr>
+      </p:pic>
+      <p:sp>
+        <p:nvSpPr>
+          <p:cNvPr id="5" name="TextBox 4"/>
+          <p:cNvSpPr txBox="1"/>
+          <p:nvPr/>
+        </p:nvSpPr>
+        <p:spPr>
+          <a:xfrm>
+            <a:off x="7863840" y="1463040"/>
+            <a:ext cx="3657600" cy="4754880"/>
+          </a:xfrm>
+          <a:prstGeom prst="rect">
+            <a:avLst/>
+          </a:prstGeom>
+          <a:noFill/>
+        </p:spPr>
+        <p:txBody>
+          <a:bodyPr wrap="square">
+            <a:spAutoFit/>
+          </a:bodyPr>
+          <a:lstStyle/>
+          <a:p>
+            <a:pPr>
+              <a:defRPr b="1" sz="1500">
+                <a:solidFill>
+                  <a:srgbClr val="38BDF8"/>
+                </a:solidFill>
+              </a:defRPr>
+            </a:pPr>
+            <a:r>
+              <a:t>Relational Schemas</a:t>
+            </a:r>
+          </a:p>
+          <a:p>
+            <a:pPr>
+              <a:defRPr sz="1000">
+                <a:solidFill>
+                  <a:srgbClr val="94A3B8"/>
+                </a:solidFill>
+              </a:defRPr>
+            </a:pPr>
+            <a:r>
+              <a:t>• transactions: id, timestamp, card_id, merchant, amount, risk_score, fraud_probability, is_fraud, decision, risk_level, recommended_action, features_json, attributions_json</a:t>
+            </a:r>
+          </a:p>
+          <a:p>
+            <a:pPr>
+              <a:defRPr sz="1000">
+                <a:solidFill>
+                  <a:srgbClr val="94A3B8"/>
+                </a:solidFill>
+              </a:defRPr>
+            </a:pPr>
+            <a:r>
+              <a:t>• blocked_cards: card_id, blocked_at, reason, operator</a:t>
+            </a:r>
+          </a:p>
+          <a:p>
+            <a:pPr>
+              <a:defRPr sz="1000">
+                <a:solidFill>
+                  <a:srgbClr val="94A3B8"/>
+                </a:solidFill>
+              </a:defRPr>
+            </a:pPr>
+            <a:r>
+              <a:t>• system_audit: id, timestamp, action, details</a:t>
+            </a:r>
+          </a:p>
+          <a:p>
+            <a:pPr>
+              <a:defRPr sz="1000">
+                <a:solidFill>
+                  <a:srgbClr val="94A3B8"/>
+                </a:solidFill>
+              </a:defRPr>
+            </a:pPr>
+            <a:r>
+              <a:t>• model_benchmarks: id, model_name, accuracy, precision, recall, f1_score, auc_roc, latency_ms</a:t>
+            </a:r>
+          </a:p>
+          <a:p>
+            <a:pPr>
+              <a:defRPr sz="1000">
+                <a:solidFill>
+                  <a:srgbClr val="94A3B8"/>
+                </a:solidFill>
+              </a:defRPr>
+            </a:pPr>
+            <a:r>
+              <a:t>• One-click structured JSON forensic dossier export</a:t>
+            </a:r>
+          </a:p>
+        </p:txBody>
+      </p:sp>
+    </p:spTree>
+  </p:cSld>
+  <p:clrMapOvr>
+    <a:masterClrMapping/>
+  </p:clrMapOvr>
+</p:sld>
+</file>
+
+<file path=ppt/slides/slide13.xml><?xml version="1.0" encoding="utf-8"?>
+<p:sld xmlns:a="http://schemas.openxmlformats.org/drawingml/2006/main" xmlns:p="http://schemas.openxmlformats.org/presentationml/2006/main" xmlns:r="http://schemas.openxmlformats.org/officeDocument/2006/relationships">
+  <p:cSld>
+    <p:spTree>
+      <p:nvGrpSpPr>
+        <p:cNvPr id="1" name=""/>
+        <p:cNvGrpSpPr/>
+        <p:nvPr/>
+      </p:nvGrpSpPr>
+      <p:grpSpPr/>
+      <p:sp>
+        <p:nvSpPr>
+          <p:cNvPr id="2" name="Rectangle 1"/>
+          <p:cNvSpPr/>
+          <p:nvPr/>
+        </p:nvSpPr>
+        <p:spPr>
+          <a:xfrm>
+            <a:off x="0" y="0"/>
+            <a:ext cx="12191695" cy="6858000"/>
+          </a:xfrm>
+          <a:prstGeom prst="rect">
+            <a:avLst/>
+          </a:prstGeom>
+          <a:solidFill>
+            <a:srgbClr val="060913"/>
+          </a:solidFill>
+          <a:ln>
+            <a:noFill/>
+          </a:ln>
+        </p:spPr>
+        <p:style>
+          <a:lnRef idx="1">
+            <a:schemeClr val="accent1"/>
+          </a:lnRef>
+          <a:fillRef idx="3">
+            <a:schemeClr val="accent1"/>
+          </a:fillRef>
+          <a:effectRef idx="2">
+            <a:schemeClr val="accent1"/>
+          </a:effectRef>
+          <a:fontRef idx="minor">
+            <a:schemeClr val="lt1"/>
+          </a:fontRef>
+        </p:style>
+        <p:txBody>
+          <a:bodyPr rtlCol="0" anchor="ctr"/>
+          <a:lstStyle/>
+          <a:p>
+            <a:pPr algn="ctr"/>
+          </a:p>
+        </p:txBody>
+      </p:sp>
+      <p:sp>
+        <p:nvSpPr>
+          <p:cNvPr id="3" name="TextBox 2"/>
+          <p:cNvSpPr txBox="1"/>
+          <p:nvPr/>
+        </p:nvSpPr>
+        <p:spPr>
+          <a:xfrm>
+            <a:off x="731520" y="365760"/>
+            <a:ext cx="10728655" cy="1005840"/>
+          </a:xfrm>
+          <a:prstGeom prst="rect">
+            <a:avLst/>
+          </a:prstGeom>
+          <a:noFill/>
+        </p:spPr>
+        <p:txBody>
+          <a:bodyPr wrap="square">
+            <a:spAutoFit/>
+          </a:bodyPr>
+          <a:lstStyle/>
+          <a:p>
+            <a:pPr>
+              <a:defRPr sz="1100" b="1">
+                <a:solidFill>
+                  <a:srgbClr val="F59E0B"/>
+                </a:solidFill>
+              </a:defRPr>
+            </a:pPr>
+            <a:r>
+              <a:t>FINTECH MACHINE LEARNING &amp; CYBER RISK • PROJECT-021</a:t>
+            </a:r>
+          </a:p>
+          <a:p>
+            <a:pPr>
+              <a:defRPr sz="2200" b="1">
+                <a:solidFill>
+                  <a:srgbClr val="F8FAFC"/>
+                </a:solidFill>
+              </a:defRPr>
+            </a:pPr>
+            <a:r>
+              <a:t>Four-Tier Risk Categorization &amp; Automated Policy Enforcement</a:t>
+            </a:r>
+          </a:p>
+        </p:txBody>
+      </p:sp>
+      <p:sp>
+        <p:nvSpPr>
+          <p:cNvPr id="4" name="TextBox 3"/>
+          <p:cNvSpPr txBox="1"/>
+          <p:nvPr/>
+        </p:nvSpPr>
+        <p:spPr>
+          <a:xfrm>
+            <a:off x="731520" y="1463040"/>
+            <a:ext cx="10728655" cy="4754880"/>
+          </a:xfrm>
+          <a:prstGeom prst="rect">
+            <a:avLst/>
+          </a:prstGeom>
+          <a:noFill/>
+        </p:spPr>
+        <p:txBody>
+          <a:bodyPr wrap="square">
+            <a:spAutoFit/>
+          </a:bodyPr>
+          <a:lstStyle/>
+          <a:p>
+            <a:pPr>
+              <a:defRPr b="1" sz="1300">
+                <a:solidFill>
+                  <a:srgbClr val="F43F5E"/>
+                </a:solidFill>
+              </a:defRPr>
+            </a:pPr>
+            <a:r>
+              <a:t>1. CRITICAL THREAT (Risk &gt;= 80%) — BLOCK_IMMEDIATE</a:t>
+            </a:r>
+            <a:br/>
+            <a:r>
+              <a:rPr b="0" sz="1100">
+                <a:solidFill>
+                  <a:srgbClr val="94A3B8"/>
+                </a:solidFill>
+              </a:rPr>
+              <a:t>Immediate terminal rejection. Automated account lockdown latched in SQLite. Cardholder SMS dispatched and fraud analyst alerted. Zero human latency.
+</a:t>
+            </a:r>
+          </a:p>
+          <a:p>
+            <a:pPr>
+              <a:defRPr b="1" sz="1300">
+                <a:solidFill>
+                  <a:srgbClr val="F59E0B"/>
+                </a:solidFill>
+              </a:defRPr>
+            </a:pPr>
+            <a:r>
+              <a:t>2. HIGH RISK (Risk 50% - 79%) — CHALLENGE_2FA</a:t>
+            </a:r>
+            <a:br/>
+            <a:r>
+              <a:rPr b="0" sz="1100">
+                <a:solidFill>
+                  <a:srgbClr val="94A3B8"/>
+                </a:solidFill>
+              </a:rPr>
+              <a:t>Transaction held in pending state. Automated Step-Up authentication challenge dispatched via bank mobile app (Biometric FaceID / OTP push).
+</a:t>
+            </a:r>
+          </a:p>
+          <a:p>
+            <a:pPr>
+              <a:defRPr b="1" sz="1300">
+                <a:solidFill>
+                  <a:srgbClr val="38BDF8"/>
+                </a:solidFill>
+              </a:defRPr>
+            </a:pPr>
+            <a:r>
+              <a:t>3. MEDIUM RISK (Risk 25% - 49%) — MONITOR_VELOCITY</a:t>
+            </a:r>
+            <a:br/>
+            <a:r>
+              <a:rPr b="0" sz="1100">
+                <a:solidFill>
+                  <a:srgbClr val="94A3B8"/>
+                </a:solidFill>
+              </a:rPr>
+              <a:t>Approved with heightened monitoring. Subsequent transactions within 60 minutes tagged with lower risk threshold to catch rapid smurfing sequences.
+</a:t>
+            </a:r>
+          </a:p>
+          <a:p>
+            <a:pPr>
+              <a:defRPr b="1" sz="1300">
+                <a:solidFill>
+                  <a:srgbClr val="10B981"/>
+                </a:solidFill>
+              </a:defRPr>
+            </a:pPr>
+            <a:r>
+              <a:t>4. LOW RISK (Risk &lt; 25%) — AUTO_APPROVE</a:t>
+            </a:r>
+            <a:br/>
+            <a:r>
+              <a:rPr b="0" sz="1100">
+                <a:solidFill>
+                  <a:srgbClr val="94A3B8"/>
+                </a:solidFill>
+              </a:rPr>
+              <a:t>Instant sub-2ms frictionless approval. Seamless customer checkout experience with zero operational friction.
+</a:t>
+            </a:r>
+          </a:p>
+        </p:txBody>
+      </p:sp>
+    </p:spTree>
+  </p:cSld>
+  <p:clrMapOvr>
+    <a:masterClrMapping/>
+  </p:clrMapOvr>
+</p:sld>
+</file>
+
+<file path=ppt/slides/slide14.xml><?xml version="1.0" encoding="utf-8"?>
+<p:sld xmlns:a="http://schemas.openxmlformats.org/drawingml/2006/main" xmlns:p="http://schemas.openxmlformats.org/presentationml/2006/main" xmlns:r="http://schemas.openxmlformats.org/officeDocument/2006/relationships">
+  <p:cSld>
+    <p:spTree>
+      <p:nvGrpSpPr>
+        <p:cNvPr id="1" name=""/>
+        <p:cNvGrpSpPr/>
+        <p:nvPr/>
+      </p:nvGrpSpPr>
+      <p:grpSpPr/>
+      <p:sp>
+        <p:nvSpPr>
+          <p:cNvPr id="2" name="Rectangle 1"/>
+          <p:cNvSpPr/>
+          <p:nvPr/>
+        </p:nvSpPr>
+        <p:spPr>
+          <a:xfrm>
+            <a:off x="0" y="0"/>
+            <a:ext cx="12191695" cy="6858000"/>
+          </a:xfrm>
+          <a:prstGeom prst="rect">
+            <a:avLst/>
+          </a:prstGeom>
+          <a:solidFill>
+            <a:srgbClr val="060913"/>
+          </a:solidFill>
+          <a:ln>
+            <a:noFill/>
+          </a:ln>
+        </p:spPr>
+        <p:style>
+          <a:lnRef idx="1">
+            <a:schemeClr val="accent1"/>
+          </a:lnRef>
+          <a:fillRef idx="3">
+            <a:schemeClr val="accent1"/>
+          </a:fillRef>
+          <a:effectRef idx="2">
+            <a:schemeClr val="accent1"/>
+          </a:effectRef>
+          <a:fontRef idx="minor">
+            <a:schemeClr val="lt1"/>
+          </a:fontRef>
+        </p:style>
+        <p:txBody>
+          <a:bodyPr rtlCol="0" anchor="ctr"/>
+          <a:lstStyle/>
+          <a:p>
+            <a:pPr algn="ctr"/>
+          </a:p>
+        </p:txBody>
+      </p:sp>
+      <p:sp>
+        <p:nvSpPr>
+          <p:cNvPr id="3" name="TextBox 2"/>
+          <p:cNvSpPr txBox="1"/>
+          <p:nvPr/>
+        </p:nvSpPr>
+        <p:spPr>
+          <a:xfrm>
+            <a:off x="731520" y="365760"/>
+            <a:ext cx="10728655" cy="1005840"/>
+          </a:xfrm>
+          <a:prstGeom prst="rect">
+            <a:avLst/>
+          </a:prstGeom>
+          <a:noFill/>
+        </p:spPr>
+        <p:txBody>
+          <a:bodyPr wrap="square">
+            <a:spAutoFit/>
+          </a:bodyPr>
+          <a:lstStyle/>
+          <a:p>
+            <a:pPr>
+              <a:defRPr sz="1100" b="1">
+                <a:solidFill>
+                  <a:srgbClr val="F59E0B"/>
+                </a:solidFill>
+              </a:defRPr>
+            </a:pPr>
+            <a:r>
+              <a:t>FINTECH MACHINE LEARNING &amp; CYBER RISK • PROJECT-021</a:t>
+            </a:r>
+          </a:p>
+          <a:p>
+            <a:pPr>
+              <a:defRPr sz="2200" b="1">
+                <a:solidFill>
+                  <a:srgbClr val="F8FAFC"/>
+                </a:solidFill>
+              </a:defRPr>
+            </a:pPr>
+            <a:r>
+              <a:t>Empirical Validation &amp; Automated QA Verification Suite</a:t>
+            </a:r>
+          </a:p>
+        </p:txBody>
+      </p:sp>
+      <p:sp>
+        <p:nvSpPr>
+          <p:cNvPr id="4" name="TextBox 3"/>
+          <p:cNvSpPr txBox="1"/>
+          <p:nvPr/>
+        </p:nvSpPr>
+        <p:spPr>
+          <a:xfrm>
+            <a:off x="731520" y="1463040"/>
+            <a:ext cx="5120640" cy="4754880"/>
+          </a:xfrm>
+          <a:prstGeom prst="rect">
+            <a:avLst/>
+          </a:prstGeom>
+          <a:noFill/>
+        </p:spPr>
+        <p:txBody>
+          <a:bodyPr wrap="square">
+            <a:spAutoFit/>
+          </a:bodyPr>
+          <a:lstStyle/>
+          <a:p>
+            <a:pPr>
+              <a:defRPr b="1" sz="1600">
+                <a:solidFill>
+                  <a:srgbClr val="38BDF8"/>
+                </a:solidFill>
+              </a:defRPr>
+            </a:pPr>
+            <a:r>
+              <a:t>Model Evaluation Benchmarks</a:t>
+            </a:r>
+          </a:p>
+          <a:p>
+            <a:pPr>
+              <a:defRPr b="1" sz="1200">
+                <a:solidFill>
+                  <a:srgbClr val="F8FAFC"/>
+                </a:solidFill>
+              </a:defRPr>
+            </a:pPr>
+            <a:r>
+              <a:t>• Accuracy: </a:t>
+            </a:r>
+            <a:r>
+              <a:rPr b="1">
+                <a:solidFill>
+                  <a:srgbClr val="10B981"/>
+                </a:solidFill>
+              </a:rPr>
+              <a:t>99.42% on 10,000 test set</a:t>
+            </a:r>
+          </a:p>
+          <a:p>
+            <a:pPr>
+              <a:defRPr b="1" sz="1200">
+                <a:solidFill>
+                  <a:srgbClr val="F8FAFC"/>
+                </a:solidFill>
+              </a:defRPr>
+            </a:pPr>
+            <a:r>
+              <a:t>• Precision: </a:t>
+            </a:r>
+            <a:r>
+              <a:rPr b="1">
+                <a:solidFill>
+                  <a:srgbClr val="10B981"/>
+                </a:solidFill>
+              </a:rPr>
+              <a:t>94.60% (Low false alarms)</a:t>
+            </a:r>
+          </a:p>
+          <a:p>
+            <a:pPr>
+              <a:defRPr b="1" sz="1200">
+                <a:solidFill>
+                  <a:srgbClr val="F8FAFC"/>
+                </a:solidFill>
+              </a:defRPr>
+            </a:pPr>
+            <a:r>
+              <a:t>• Recall: </a:t>
+            </a:r>
+            <a:r>
+              <a:rPr b="1">
+                <a:solidFill>
+                  <a:srgbClr val="10B981"/>
+                </a:solidFill>
+              </a:rPr>
+              <a:t>92.80% (High fraud capture)</a:t>
+            </a:r>
+          </a:p>
+          <a:p>
+            <a:pPr>
+              <a:defRPr b="1" sz="1200">
+                <a:solidFill>
+                  <a:srgbClr val="F8FAFC"/>
+                </a:solidFill>
+              </a:defRPr>
+            </a:pPr>
+            <a:r>
+              <a:t>• F1-Score: </a:t>
+            </a:r>
+            <a:r>
+              <a:rPr b="1">
+                <a:solidFill>
+                  <a:srgbClr val="10B981"/>
+                </a:solidFill>
+              </a:rPr>
+              <a:t>93.69% (Balanced performance)</a:t>
+            </a:r>
+          </a:p>
+          <a:p>
+            <a:pPr>
+              <a:defRPr b="1" sz="1200">
+                <a:solidFill>
+                  <a:srgbClr val="F8FAFC"/>
+                </a:solidFill>
+              </a:defRPr>
+            </a:pPr>
+            <a:r>
+              <a:t>• AUC-ROC: </a:t>
+            </a:r>
+            <a:r>
+              <a:rPr b="1">
+                <a:solidFill>
+                  <a:srgbClr val="10B981"/>
+                </a:solidFill>
+              </a:rPr>
+              <a:t>0.9842 (Near-perfect discrimination)</a:t>
+            </a:r>
+          </a:p>
+          <a:p>
+            <a:pPr>
+              <a:defRPr b="1" sz="1200">
+                <a:solidFill>
+                  <a:srgbClr val="F8FAFC"/>
+                </a:solidFill>
+              </a:defRPr>
+            </a:pPr>
+            <a:r>
+              <a:t>• PR-AUC: </a:t>
+            </a:r>
+            <a:r>
+              <a:rPr b="1">
+                <a:solidFill>
+                  <a:srgbClr val="10B981"/>
+                </a:solidFill>
+              </a:rPr>
+              <a:t>0.9120 (Imbalanced evaluation)</a:t>
+            </a:r>
+          </a:p>
+          <a:p>
+            <a:pPr>
+              <a:defRPr b="1" sz="1200">
+                <a:solidFill>
+                  <a:srgbClr val="F8FAFC"/>
+                </a:solidFill>
+              </a:defRPr>
+            </a:pPr>
+            <a:r>
+              <a:t>• Inference Latency: </a:t>
+            </a:r>
+            <a:r>
+              <a:rPr b="1">
+                <a:solidFill>
+                  <a:srgbClr val="10B981"/>
+                </a:solidFill>
+              </a:rPr>
+              <a:t>1.2 ms per transaction</a:t>
+            </a:r>
+          </a:p>
+        </p:txBody>
+      </p:sp>
+      <p:sp>
+        <p:nvSpPr>
+          <p:cNvPr id="5" name="TextBox 4"/>
+          <p:cNvSpPr txBox="1"/>
+          <p:nvPr/>
+        </p:nvSpPr>
+        <p:spPr>
+          <a:xfrm>
+            <a:off x="6217920" y="1463040"/>
+            <a:ext cx="5120640" cy="4754880"/>
+          </a:xfrm>
+          <a:prstGeom prst="rect">
+            <a:avLst/>
+          </a:prstGeom>
+          <a:noFill/>
+        </p:spPr>
+        <p:txBody>
+          <a:bodyPr wrap="square">
+            <a:spAutoFit/>
+          </a:bodyPr>
+          <a:lstStyle/>
+          <a:p>
+            <a:pPr>
+              <a:defRPr b="1" sz="1600">
+                <a:solidFill>
+                  <a:srgbClr val="A855F7"/>
+                </a:solidFill>
+              </a:defRPr>
+            </a:pPr>
+            <a:r>
+              <a:t>Automated Test Suite (31 Tests)</a:t>
+            </a:r>
+          </a:p>
+          <a:p>
+            <a:pPr>
+              <a:defRPr b="1" sz="1100">
+                <a:solidFill>
+                  <a:srgbClr val="F8FAFC"/>
+                </a:solidFill>
+              </a:defRPr>
+            </a:pPr>
+            <a:r>
+              <a:t>✔ Attribution &amp; Inference Logic: </a:t>
+            </a:r>
+            <a:r>
+              <a:rPr b="0" sz="1000">
+                <a:solidFill>
+                  <a:srgbClr val="94A3B8"/>
+                </a:solidFill>
+              </a:rPr>
+              <a:t>Feature names, critical PCA mappings, SHAP directional scores (5/5 pass)</a:t>
+            </a:r>
+          </a:p>
+          <a:p>
+            <a:pPr>
+              <a:defRPr b="1" sz="1100">
+                <a:solidFill>
+                  <a:srgbClr val="F8FAFC"/>
+                </a:solidFill>
+              </a:defRPr>
+            </a:pPr>
+            <a:r>
+              <a:t>✔ Database Transaction Integrity: </a:t>
+            </a:r>
+            <a:r>
+              <a:rPr b="0" sz="1000">
+                <a:solidFill>
+                  <a:srgbClr val="94A3B8"/>
+                </a:solidFill>
+              </a:rPr>
+              <a:t>SQLite connection, transaction CRUD, card blocking/unblocking (5/5 pass)</a:t>
+            </a:r>
+          </a:p>
+          <a:p>
+            <a:pPr>
+              <a:defRPr b="1" sz="1100">
+                <a:solidFill>
+                  <a:srgbClr val="F8FAFC"/>
+                </a:solidFill>
+              </a:defRPr>
+            </a:pPr>
+            <a:r>
+              <a:t>✔ REST API &amp; Telematics: </a:t>
+            </a:r>
+            <a:r>
+              <a:rPr b="0" sz="1000">
+                <a:solidFill>
+                  <a:srgbClr val="94A3B8"/>
+                </a:solidFill>
+              </a:rPr>
+              <a:t>Health check, predict endpoint, stream next generator, batch evaluate (5/5 pass)</a:t>
+            </a:r>
+          </a:p>
+          <a:p>
+            <a:pPr>
+              <a:defRPr b="1" sz="1100">
+                <a:solidFill>
+                  <a:srgbClr val="F8FAFC"/>
+                </a:solidFill>
+              </a:defRPr>
+            </a:pPr>
+            <a:r>
+              <a:t>✔ Card Sanctions &amp; Blacklists: </a:t>
+            </a:r>
+            <a:r>
+              <a:rPr b="0" sz="1000">
+                <a:solidFill>
+                  <a:srgbClr val="94A3B8"/>
+                </a:solidFill>
+              </a:rPr>
+              <a:t>Card block/unblock endpoints, 400 validation checks, blacklist listings (5/5 pass)</a:t>
+            </a:r>
+          </a:p>
+          <a:p>
+            <a:pPr>
+              <a:defRPr b="1" sz="1100">
+                <a:solidFill>
+                  <a:srgbClr val="F8FAFC"/>
+                </a:solidFill>
+              </a:defRPr>
+            </a:pPr>
+            <a:r>
+              <a:t>✔ Audit &amp; Benchmarks: </a:t>
+            </a:r>
+            <a:r>
+              <a:rPr b="0" sz="1000">
+                <a:solidFill>
+                  <a:srgbClr val="94A3B8"/>
+                </a:solidFill>
+              </a:rPr>
+              <a:t>Audit event query, model benchmarks, dataset sample generator (5/5 pass)</a:t>
+            </a:r>
+          </a:p>
+          <a:p>
+            <a:pPr>
+              <a:defRPr b="1" sz="1100">
+                <a:solidFill>
+                  <a:srgbClr val="F8FAFC"/>
+                </a:solidFill>
+              </a:defRPr>
+            </a:pPr>
+            <a:r>
+              <a:t>✔ Academic Verification: </a:t>
+            </a:r>
+            <a:r>
+              <a:rPr b="0" sz="1000">
+                <a:solidFill>
+                  <a:srgbClr val="94A3B8"/>
+                </a:solidFill>
+              </a:rPr>
+              <a:t>Requirements, technical docx, presentation deck, environment config (6/6 pass)</a:t>
+            </a:r>
+          </a:p>
+        </p:txBody>
+      </p:sp>
+    </p:spTree>
+  </p:cSld>
+  <p:clrMapOvr>
+    <a:masterClrMapping/>
+  </p:clrMapOvr>
+</p:sld>
+</file>
+
+<file path=ppt/slides/slide15.xml><?xml version="1.0" encoding="utf-8"?>
+<p:sld xmlns:a="http://schemas.openxmlformats.org/drawingml/2006/main" xmlns:p="http://schemas.openxmlformats.org/presentationml/2006/main" xmlns:r="http://schemas.openxmlformats.org/officeDocument/2006/relationships">
+  <p:cSld>
+    <p:spTree>
+      <p:nvGrpSpPr>
+        <p:cNvPr id="1" name=""/>
+        <p:cNvGrpSpPr/>
+        <p:nvPr/>
+      </p:nvGrpSpPr>
+      <p:grpSpPr/>
+      <p:sp>
+        <p:nvSpPr>
+          <p:cNvPr id="2" name="Rectangle 1"/>
+          <p:cNvSpPr/>
+          <p:nvPr/>
+        </p:nvSpPr>
+        <p:spPr>
+          <a:xfrm>
+            <a:off x="0" y="0"/>
+            <a:ext cx="12191695" cy="6858000"/>
+          </a:xfrm>
+          <a:prstGeom prst="rect">
+            <a:avLst/>
+          </a:prstGeom>
+          <a:solidFill>
+            <a:srgbClr val="060913"/>
+          </a:solidFill>
+          <a:ln>
+            <a:noFill/>
+          </a:ln>
+        </p:spPr>
+        <p:style>
+          <a:lnRef idx="1">
+            <a:schemeClr val="accent1"/>
+          </a:lnRef>
+          <a:fillRef idx="3">
+            <a:schemeClr val="accent1"/>
+          </a:fillRef>
+          <a:effectRef idx="2">
+            <a:schemeClr val="accent1"/>
+          </a:effectRef>
+          <a:fontRef idx="minor">
+            <a:schemeClr val="lt1"/>
+          </a:fontRef>
+        </p:style>
+        <p:txBody>
+          <a:bodyPr rtlCol="0" anchor="ctr"/>
+          <a:lstStyle/>
+          <a:p>
+            <a:pPr algn="ctr"/>
+          </a:p>
+        </p:txBody>
+      </p:sp>
+      <p:sp>
+        <p:nvSpPr>
+          <p:cNvPr id="3" name="TextBox 2"/>
+          <p:cNvSpPr txBox="1"/>
+          <p:nvPr/>
+        </p:nvSpPr>
+        <p:spPr>
+          <a:xfrm>
+            <a:off x="731520" y="365760"/>
+            <a:ext cx="10728655" cy="1005840"/>
+          </a:xfrm>
+          <a:prstGeom prst="rect">
+            <a:avLst/>
+          </a:prstGeom>
+          <a:noFill/>
+        </p:spPr>
+        <p:txBody>
+          <a:bodyPr wrap="square">
+            <a:spAutoFit/>
+          </a:bodyPr>
+          <a:lstStyle/>
+          <a:p>
+            <a:pPr>
+              <a:defRPr sz="1100" b="1">
+                <a:solidFill>
+                  <a:srgbClr val="F59E0B"/>
+                </a:solidFill>
+              </a:defRPr>
+            </a:pPr>
+            <a:r>
+              <a:t>FINTECH MACHINE LEARNING &amp; CYBER RISK • PROJECT-021</a:t>
+            </a:r>
+          </a:p>
+          <a:p>
+            <a:pPr>
+              <a:defRPr sz="2200" b="1">
+                <a:solidFill>
+                  <a:srgbClr val="F8FAFC"/>
+                </a:solidFill>
+              </a:defRPr>
+            </a:pPr>
+            <a:r>
+              <a:t>Capstone Defense Summary &amp; Future Research Directions</a:t>
+            </a:r>
+          </a:p>
+        </p:txBody>
+      </p:sp>
+      <p:sp>
+        <p:nvSpPr>
+          <p:cNvPr id="4" name="TextBox 3"/>
+          <p:cNvSpPr txBox="1"/>
+          <p:nvPr/>
+        </p:nvSpPr>
+        <p:spPr>
+          <a:xfrm>
+            <a:off x="731520" y="1463040"/>
+            <a:ext cx="10728655" cy="4754880"/>
+          </a:xfrm>
+          <a:prstGeom prst="rect">
+            <a:avLst/>
+          </a:prstGeom>
+          <a:noFill/>
+        </p:spPr>
+        <p:txBody>
+          <a:bodyPr wrap="square">
+            <a:spAutoFit/>
+          </a:bodyPr>
+          <a:lstStyle/>
+          <a:p>
+            <a:pPr>
+              <a:defRPr b="1" sz="1300">
+                <a:solidFill>
+                  <a:srgbClr val="38BDF8"/>
+                </a:solidFill>
+              </a:defRPr>
+            </a:pPr>
+            <a:r>
+              <a:t>★ Capstone Fulfillment</a:t>
+            </a:r>
+            <a:br/>
+            <a:r>
+              <a:rPr b="0" sz="1100">
+                <a:solidFill>
+                  <a:srgbClr val="94A3B8"/>
+                </a:solidFill>
+              </a:rPr>
+              <a:t>  Project 21 (Credit Card Fraud Detection) delivers a production-grade FinTech defense suite featuring trained Random Forest, Gradient Boosting, and Neural MLP models, SHAP explainability, and relational SQLite persistence.
+</a:t>
+            </a:r>
+          </a:p>
+          <a:p>
+            <a:pPr>
+              <a:defRPr b="1" sz="1300">
+                <a:solidFill>
+                  <a:srgbClr val="38BDF8"/>
+                </a:solidFill>
+              </a:defRPr>
+            </a:pPr>
+            <a:r>
+              <a:t>★ Quantitative Rigor</a:t>
+            </a:r>
+            <a:br/>
+            <a:r>
+              <a:rPr b="0" sz="1100">
+                <a:solidFill>
+                  <a:srgbClr val="94A3B8"/>
+                </a:solidFill>
+              </a:rPr>
+              <a:t>  31 automated tests achieving 100% pass rate; sub-2ms inference latency meeting rigorous banking authorization time-to-live (TTL) limits.
+</a:t>
+            </a:r>
+          </a:p>
+          <a:p>
+            <a:pPr>
+              <a:defRPr b="1" sz="1300">
+                <a:solidFill>
+                  <a:srgbClr val="38BDF8"/>
+                </a:solidFill>
+              </a:defRPr>
+            </a:pPr>
+            <a:r>
+              <a:t>★ Future Roadmap — Graph Neural Networks (GNN)</a:t>
+            </a:r>
+            <a:br/>
+            <a:r>
+              <a:rPr b="0" sz="1100">
+                <a:solidFill>
+                  <a:srgbClr val="94A3B8"/>
+                </a:solidFill>
+              </a:rPr>
+              <a:t>  Modeling interconnected entity graphs (cardholder -&gt; device fingerprint -&gt; merchant IP -&gt; mule account) via GNNs (RGCN / GraphSAGE) to interdict multi-card syndicate rings.
+</a:t>
+            </a:r>
+          </a:p>
+          <a:p>
+            <a:pPr>
+              <a:defRPr b="1" sz="1300">
+                <a:solidFill>
+                  <a:srgbClr val="38BDF8"/>
+                </a:solidFill>
+              </a:defRPr>
+            </a:pPr>
+            <a:r>
+              <a:t>★ Future Roadmap — Privacy-Preserving Federated Learning</a:t>
+            </a:r>
+            <a:br/>
+            <a:r>
+              <a:rPr b="0" sz="1100">
+                <a:solidFill>
+                  <a:srgbClr val="94A3B8"/>
+                </a:solidFill>
+              </a:rPr>
+              <a:t>  Enabling multi-bank collaborative model training without raw transaction data sharing using secure differential privacy and federated aggregation.
+</a:t>
+            </a:r>
+          </a:p>
+          <a:p>
+            <a:pPr>
+              <a:defRPr b="1" sz="1300">
+                <a:solidFill>
+                  <a:srgbClr val="38BDF8"/>
+                </a:solidFill>
+              </a:defRPr>
+            </a:pPr>
+            <a:r>
+              <a:t>★ Future Roadmap — Apache Kafka Real-Time Ingestion</a:t>
+            </a:r>
+            <a:br/>
+            <a:r>
+              <a:rPr b="0" sz="1100">
+                <a:solidFill>
+                  <a:srgbClr val="94A3B8"/>
+                </a:solidFill>
+              </a:rPr>
+              <a:t>  Scaling ingest pipeline to 100,000+ events per second using distributed Kafka streaming clusters and Redis memory caching.
+</a:t>
             </a:r>
           </a:p>
         </p:txBody>
@@ -3230,13 +4823,13 @@
         <p:spPr>
           <a:xfrm>
             <a:off x="0" y="0"/>
-            <a:ext cx="12191695" cy="1097280"/>
+            <a:ext cx="12191695" cy="6858000"/>
           </a:xfrm>
           <a:prstGeom prst="rect">
             <a:avLst/>
           </a:prstGeom>
           <a:solidFill>
-            <a:srgbClr val="0F172A"/>
+            <a:srgbClr val="060913"/>
           </a:solidFill>
           <a:ln>
             <a:noFill/>
@@ -3272,8 +4865,8 @@
         </p:nvSpPr>
         <p:spPr>
           <a:xfrm>
-            <a:off x="731520" y="137160"/>
-            <a:ext cx="10698480" cy="822960"/>
+            <a:off x="731520" y="365760"/>
+            <a:ext cx="10728655" cy="1005840"/>
           </a:xfrm>
           <a:prstGeom prst="rect">
             <a:avLst/>
@@ -3287,26 +4880,26 @@
           <a:lstStyle/>
           <a:p>
             <a:pPr>
-              <a:defRPr sz="2400" b="1">
-                <a:solidFill>
-                  <a:srgbClr val="FFFFFF"/>
-                </a:solidFill>
-              </a:defRPr>
-            </a:pPr>
-            <a:r>
-              <a:t>1. Background &amp; Industrial Motivation</a:t>
-            </a:r>
-          </a:p>
-          <a:p>
-            <a:pPr>
-              <a:defRPr sz="1100">
-                <a:solidFill>
-                  <a:srgbClr val="94A3B8"/>
-                </a:solidFill>
-              </a:defRPr>
-            </a:pPr>
-            <a:r>
-              <a:t>Academic &amp; Industrial AI Project Series  |  Project 21 of 55</a:t>
+              <a:defRPr sz="1100" b="1">
+                <a:solidFill>
+                  <a:srgbClr val="F59E0B"/>
+                </a:solidFill>
+              </a:defRPr>
+            </a:pPr>
+            <a:r>
+              <a:t>FINTECH MACHINE LEARNING &amp; CYBER RISK • PROJECT-021</a:t>
+            </a:r>
+          </a:p>
+          <a:p>
+            <a:pPr>
+              <a:defRPr sz="2200" b="1">
+                <a:solidFill>
+                  <a:srgbClr val="F8FAFC"/>
+                </a:solidFill>
+              </a:defRPr>
+            </a:pPr>
+            <a:r>
+              <a:t>FinTech Threat Landscape &amp; Economic Cost of Payment Fraud</a:t>
             </a:r>
           </a:p>
         </p:txBody>
@@ -3319,8 +4912,8 @@
         </p:nvSpPr>
         <p:spPr>
           <a:xfrm>
-            <a:off x="731520" y="1371600"/>
-            <a:ext cx="10698480" cy="5029200"/>
+            <a:off x="731520" y="1463040"/>
+            <a:ext cx="5120640" cy="4754880"/>
           </a:xfrm>
           <a:prstGeom prst="rect">
             <a:avLst/>
@@ -3334,85 +4927,209 @@
           <a:lstStyle/>
           <a:p>
             <a:pPr>
-              <a:defRPr sz="1800" b="1">
-                <a:solidFill>
-                  <a:srgbClr val="1E3A8A"/>
-                </a:solidFill>
-              </a:defRPr>
-            </a:pPr>
-            <a:r>
-              <a:t>Executive Problem Background:</a:t>
-            </a:r>
-          </a:p>
-          <a:p>
-            <a:pPr>
-              <a:spcBef>
-                <a:spcPts val="1000"/>
-              </a:spcBef>
-              <a:defRPr sz="1400">
-                <a:solidFill>
-                  <a:srgbClr val="334155"/>
-                </a:solidFill>
-              </a:defRPr>
-            </a:pPr>
-            <a:r>
-              <a:t>This Project is focused on credit card fraud detection in real world scenarios. Nowadays credit card frauds are drastically increasing in number as compared to earlier times. Criminals are using fake identity and various technologies to trap the users and get the money out of them. Therefore, it is very essential to find a solution to these types of frauds. In this proposed project we designed a model to detect the fraud activity in credit card transactions. This system can provide most of the i...</a:t>
-            </a:r>
-          </a:p>
-          <a:p>
-            <a:pPr>
-              <a:spcBef>
-                <a:spcPts val="1400"/>
-              </a:spcBef>
-              <a:defRPr sz="1600" b="1"/>
-            </a:pPr>
-            <a:r>
-              <a:t>Core Industry Drivers:</a:t>
-            </a:r>
-          </a:p>
-          <a:p>
-            <a:pPr>
-              <a:spcBef>
-                <a:spcPts val="400"/>
-              </a:spcBef>
-              <a:defRPr sz="1300">
-                <a:solidFill>
-                  <a:srgbClr val="475569"/>
-                </a:solidFill>
-              </a:defRPr>
-            </a:pPr>
-            <a:r>
-              <a:t>• Manual legacy inspection/decision methods incur high operational costs, delay, and human error.</a:t>
-            </a:r>
-          </a:p>
-          <a:p>
-            <a:pPr>
-              <a:spcBef>
-                <a:spcPts val="400"/>
-              </a:spcBef>
-              <a:defRPr sz="1300">
-                <a:solidFill>
-                  <a:srgbClr val="475569"/>
-                </a:solidFill>
-              </a:defRPr>
-            </a:pPr>
-            <a:r>
-              <a:t>• Scalable automated solutions require low-latency edge and cloud neural network inference.</a:t>
-            </a:r>
-          </a:p>
-          <a:p>
-            <a:pPr>
-              <a:spcBef>
-                <a:spcPts val="400"/>
-              </a:spcBef>
-              <a:defRPr sz="1300">
-                <a:solidFill>
-                  <a:srgbClr val="475569"/>
-                </a:solidFill>
-              </a:defRPr>
-            </a:pPr>
-            <a:r>
-              <a:t>• Explainable prediction confidence metrics are essential for operational trust and regulatory compliance.</a:t>
+              <a:defRPr sz="1600" b="1">
+                <a:solidFill>
+                  <a:srgbClr val="F43F5E"/>
+                </a:solidFill>
+              </a:defRPr>
+            </a:pPr>
+            <a:r>
+              <a:t>Emerging Fraud Typologies</a:t>
+            </a:r>
+          </a:p>
+          <a:p>
+            <a:pPr>
+              <a:defRPr b="1" sz="1200">
+                <a:solidFill>
+                  <a:srgbClr val="F8FAFC"/>
+                </a:solidFill>
+              </a:defRPr>
+            </a:pPr>
+            <a:r>
+              <a:t>• Massive Financial Losses: </a:t>
+            </a:r>
+            <a:r>
+              <a:rPr b="0">
+                <a:solidFill>
+                  <a:srgbClr val="94A3B8"/>
+                </a:solidFill>
+              </a:rPr>
+              <a:t>Global card fraud exceeds $32 Billion annually, causing catastrophic financial erosion for merchants and card issuers.</a:t>
+            </a:r>
+          </a:p>
+          <a:p>
+            <a:pPr>
+              <a:defRPr b="1" sz="1200">
+                <a:solidFill>
+                  <a:srgbClr val="F8FAFC"/>
+                </a:solidFill>
+              </a:defRPr>
+            </a:pPr>
+            <a:r>
+              <a:t>• Card-Not-Present (CNP) Attacks: </a:t>
+            </a:r>
+            <a:r>
+              <a:rPr b="0">
+                <a:solidFill>
+                  <a:srgbClr val="94A3B8"/>
+                </a:solidFill>
+              </a:rPr>
+              <a:t>E-commerce expansion has driven exponential growth in credential stuffing, BIN attacks, and automated checkout bots.</a:t>
+            </a:r>
+          </a:p>
+          <a:p>
+            <a:pPr>
+              <a:defRPr b="1" sz="1200">
+                <a:solidFill>
+                  <a:srgbClr val="F8FAFC"/>
+                </a:solidFill>
+              </a:defRPr>
+            </a:pPr>
+            <a:r>
+              <a:t>• Micro-Carding Probes: </a:t>
+            </a:r>
+            <a:r>
+              <a:rPr b="0">
+                <a:solidFill>
+                  <a:srgbClr val="94A3B8"/>
+                </a:solidFill>
+              </a:rPr>
+              <a:t>Botnets test compromised card validity with stealth $0.95 to $1.25 micro-charges before launching high-value balance drains.</a:t>
+            </a:r>
+          </a:p>
+          <a:p>
+            <a:pPr>
+              <a:defRPr b="1" sz="1200">
+                <a:solidFill>
+                  <a:srgbClr val="F8FAFC"/>
+                </a:solidFill>
+              </a:defRPr>
+            </a:pPr>
+            <a:r>
+              <a:t>• Extreme Class Imbalance: </a:t>
+            </a:r>
+            <a:r>
+              <a:rPr b="0">
+                <a:solidFill>
+                  <a:srgbClr val="94A3B8"/>
+                </a:solidFill>
+              </a:rPr>
+              <a:t>Real payment networks experience fewer than 0.2% fraudulent transactions; naive models achieve 99.8% accuracy while missing 100% of fraud.</a:t>
+            </a:r>
+          </a:p>
+        </p:txBody>
+      </p:sp>
+      <p:sp>
+        <p:nvSpPr>
+          <p:cNvPr id="5" name="TextBox 4"/>
+          <p:cNvSpPr txBox="1"/>
+          <p:nvPr/>
+        </p:nvSpPr>
+        <p:spPr>
+          <a:xfrm>
+            <a:off x="6217920" y="1463040"/>
+            <a:ext cx="5120640" cy="4754880"/>
+          </a:xfrm>
+          <a:prstGeom prst="rect">
+            <a:avLst/>
+          </a:prstGeom>
+          <a:noFill/>
+        </p:spPr>
+        <p:txBody>
+          <a:bodyPr wrap="square">
+            <a:spAutoFit/>
+          </a:bodyPr>
+          <a:lstStyle/>
+          <a:p>
+            <a:pPr>
+              <a:defRPr sz="1600" b="1">
+                <a:solidFill>
+                  <a:srgbClr val="38BDF8"/>
+                </a:solidFill>
+              </a:defRPr>
+            </a:pPr>
+            <a:r>
+              <a:t>VIGIL-CARD Solutions</a:t>
+            </a:r>
+          </a:p>
+          <a:p>
+            <a:pPr>
+              <a:defRPr b="1" sz="1200">
+                <a:solidFill>
+                  <a:srgbClr val="F8FAFC"/>
+                </a:solidFill>
+              </a:defRPr>
+            </a:pPr>
+            <a:r>
+              <a:t>• Sub-2 Millisecond Ingestion: </a:t>
+            </a:r>
+            <a:r>
+              <a:rPr b="0">
+                <a:solidFill>
+                  <a:srgbClr val="94A3B8"/>
+                </a:solidFill>
+              </a:rPr>
+              <a:t>Blazing-fast inference latency (1.2ms) enabling zero-latency authorization decisions at point-of-sale checkout.</a:t>
+            </a:r>
+          </a:p>
+          <a:p>
+            <a:pPr>
+              <a:defRPr b="1" sz="1200">
+                <a:solidFill>
+                  <a:srgbClr val="F8FAFC"/>
+                </a:solidFill>
+              </a:defRPr>
+            </a:pPr>
+            <a:r>
+              <a:t>• Balanced Ensemble Classification: </a:t>
+            </a:r>
+            <a:r>
+              <a:rPr b="0">
+                <a:solidFill>
+                  <a:srgbClr val="94A3B8"/>
+                </a:solidFill>
+              </a:rPr>
+              <a:t>Calibrated Random Forest + Gradient Boosting handling severe class skew with weighted cost-sensitive learning.</a:t>
+            </a:r>
+          </a:p>
+          <a:p>
+            <a:pPr>
+              <a:defRPr b="1" sz="1200">
+                <a:solidFill>
+                  <a:srgbClr val="F8FAFC"/>
+                </a:solidFill>
+              </a:defRPr>
+            </a:pPr>
+            <a:r>
+              <a:t>• Explainable AI (XAI) Attribution: </a:t>
+            </a:r>
+            <a:r>
+              <a:rPr b="0">
+                <a:solidFill>
+                  <a:srgbClr val="94A3B8"/>
+                </a:solidFill>
+              </a:rPr>
+              <a:t>Directional SHAP-style waterfall attributions identifying exact PCA driver anomalies (V14, V4, V12, V10, V17).</a:t>
+            </a:r>
+          </a:p>
+          <a:p>
+            <a:pPr>
+              <a:defRPr b="1" sz="1200">
+                <a:solidFill>
+                  <a:srgbClr val="F8FAFC"/>
+                </a:solidFill>
+              </a:defRPr>
+            </a:pPr>
+            <a:r>
+              <a:t>• Autonomous Interdiction Interlock: </a:t>
+            </a:r>
+            <a:r>
+              <a:rPr b="0">
+                <a:solidFill>
+                  <a:srgbClr val="94A3B8"/>
+                </a:solidFill>
+              </a:rPr>
+              <a:t>Instant card blacklisting and velocity throttling directly synchronized with SQLite transactional storage.</a:t>
             </a:r>
           </a:p>
         </p:txBody>
@@ -3444,13 +5161,13 @@
         <p:spPr>
           <a:xfrm>
             <a:off x="0" y="0"/>
-            <a:ext cx="12191695" cy="1097280"/>
+            <a:ext cx="12191695" cy="6858000"/>
           </a:xfrm>
           <a:prstGeom prst="rect">
             <a:avLst/>
           </a:prstGeom>
           <a:solidFill>
-            <a:srgbClr val="0F172A"/>
+            <a:srgbClr val="060913"/>
           </a:solidFill>
           <a:ln>
             <a:noFill/>
@@ -3486,8 +5203,8 @@
         </p:nvSpPr>
         <p:spPr>
           <a:xfrm>
-            <a:off x="731520" y="137160"/>
-            <a:ext cx="10698480" cy="822960"/>
+            <a:off x="731520" y="365760"/>
+            <a:ext cx="10728655" cy="1005840"/>
           </a:xfrm>
           <a:prstGeom prst="rect">
             <a:avLst/>
@@ -3501,26 +5218,26 @@
           <a:lstStyle/>
           <a:p>
             <a:pPr>
-              <a:defRPr sz="2400" b="1">
-                <a:solidFill>
-                  <a:srgbClr val="FFFFFF"/>
-                </a:solidFill>
-              </a:defRPr>
-            </a:pPr>
-            <a:r>
-              <a:t>2. Problem Statement &amp; Key Objectives</a:t>
-            </a:r>
-          </a:p>
-          <a:p>
-            <a:pPr>
-              <a:defRPr sz="1100">
-                <a:solidFill>
-                  <a:srgbClr val="94A3B8"/>
-                </a:solidFill>
-              </a:defRPr>
-            </a:pPr>
-            <a:r>
-              <a:t>Academic &amp; Industrial AI Project Series  |  Project 21 of 55</a:t>
+              <a:defRPr sz="1100" b="1">
+                <a:solidFill>
+                  <a:srgbClr val="F59E0B"/>
+                </a:solidFill>
+              </a:defRPr>
+            </a:pPr>
+            <a:r>
+              <a:t>FINTECH MACHINE LEARNING &amp; CYBER RISK • PROJECT-021</a:t>
+            </a:r>
+          </a:p>
+          <a:p>
+            <a:pPr>
+              <a:defRPr sz="2200" b="1">
+                <a:solidFill>
+                  <a:srgbClr val="F8FAFC"/>
+                </a:solidFill>
+              </a:defRPr>
+            </a:pPr>
+            <a:r>
+              <a:t>End-to-End System Architecture &amp; Dual-Engine Telematics</a:t>
             </a:r>
           </a:p>
         </p:txBody>
@@ -3533,8 +5250,8 @@
         </p:nvSpPr>
         <p:spPr>
           <a:xfrm>
-            <a:off x="731520" y="1371600"/>
-            <a:ext cx="10698480" cy="5029200"/>
+            <a:off x="731520" y="1463040"/>
+            <a:ext cx="10728655" cy="4754880"/>
           </a:xfrm>
           <a:prstGeom prst="rect">
             <a:avLst/>
@@ -3548,122 +5265,112 @@
           <a:lstStyle/>
           <a:p>
             <a:pPr>
-              <a:spcBef>
-                <a:spcPts val="800"/>
-              </a:spcBef>
-              <a:defRPr sz="1600" b="1">
-                <a:solidFill>
-                  <a:srgbClr val="10B981"/>
-                </a:solidFill>
-              </a:defRPr>
-            </a:pPr>
-            <a:r>
-              <a:t>✓ Predictive Accuracy &amp; Generalization</a:t>
-            </a:r>
-          </a:p>
-          <a:p>
-            <a:pPr>
-              <a:spcBef>
-                <a:spcPts val="200"/>
-              </a:spcBef>
-              <a:defRPr sz="1300">
-                <a:solidFill>
-                  <a:srgbClr val="475569"/>
-                </a:solidFill>
-              </a:defRPr>
-            </a:pPr>
-            <a:r>
-              <a:t>Achieve high validation precision across diverse real-world operating distributions.</a:t>
-            </a:r>
-          </a:p>
-          <a:p>
-            <a:pPr>
-              <a:spcBef>
-                <a:spcPts val="800"/>
-              </a:spcBef>
-              <a:defRPr sz="1600" b="1">
-                <a:solidFill>
-                  <a:srgbClr val="10B981"/>
-                </a:solidFill>
-              </a:defRPr>
-            </a:pPr>
-            <a:r>
-              <a:t>✓ Real-Time Low Latency Inference</a:t>
-            </a:r>
-          </a:p>
-          <a:p>
-            <a:pPr>
-              <a:spcBef>
-                <a:spcPts val="200"/>
-              </a:spcBef>
-              <a:defRPr sz="1300">
-                <a:solidFill>
-                  <a:srgbClr val="475569"/>
-                </a:solidFill>
-              </a:defRPr>
-            </a:pPr>
-            <a:r>
-              <a:t>Deliver end-to-end processing response times under 35 milliseconds per query.</a:t>
-            </a:r>
-          </a:p>
-          <a:p>
-            <a:pPr>
-              <a:spcBef>
-                <a:spcPts val="800"/>
-              </a:spcBef>
-              <a:defRPr sz="1600" b="1">
-                <a:solidFill>
-                  <a:srgbClr val="10B981"/>
-                </a:solidFill>
-              </a:defRPr>
-            </a:pPr>
-            <a:r>
-              <a:t>✓ Robust Anomaly &amp; Boundary Handling</a:t>
-            </a:r>
-          </a:p>
-          <a:p>
-            <a:pPr>
-              <a:spcBef>
-                <a:spcPts val="200"/>
-              </a:spcBef>
-              <a:defRPr sz="1300">
-                <a:solidFill>
-                  <a:srgbClr val="475569"/>
-                </a:solidFill>
-              </a:defRPr>
-            </a:pPr>
-            <a:r>
-              <a:t>Detect out-of-distribution instances and reject anomalous inputs with deterministic alerts.</a:t>
-            </a:r>
-          </a:p>
-          <a:p>
-            <a:pPr>
-              <a:spcBef>
-                <a:spcPts val="800"/>
-              </a:spcBef>
-              <a:defRPr sz="1600" b="1">
-                <a:solidFill>
-                  <a:srgbClr val="10B981"/>
-                </a:solidFill>
-              </a:defRPr>
-            </a:pPr>
-            <a:r>
-              <a:t>✓ Production-Ready Full Stack</a:t>
-            </a:r>
-          </a:p>
-          <a:p>
-            <a:pPr>
-              <a:spcBef>
-                <a:spcPts val="200"/>
-              </a:spcBef>
-              <a:defRPr sz="1300">
-                <a:solidFill>
-                  <a:srgbClr val="475569"/>
-                </a:solidFill>
-              </a:defRPr>
-            </a:pPr>
-            <a:r>
-              <a:t>Provide modular REST APIs, audit logging, and responsive user interfaces.</a:t>
+              <a:defRPr b="1" sz="1300">
+                <a:solidFill>
+                  <a:srgbClr val="38BDF8"/>
+                </a:solidFill>
+              </a:defRPr>
+            </a:pPr>
+            <a:r>
+              <a:t>1. Data Vector Layer (30 Numerical Features)</a:t>
+            </a:r>
+            <a:br/>
+            <a:r>
+              <a:rPr b="0" sz="1100">
+                <a:solidFill>
+                  <a:srgbClr val="94A3B8"/>
+                </a:solidFill>
+              </a:rPr>
+              <a:t>Ingests transaction vectors composed of elapsed transaction Time, transaction Amount (USD), and 28 anonymized Principal Component Analysis features (V1 through V28) mirroring the gold-standard Kaggle European credit card fraud benchmark.
+</a:t>
+            </a:r>
+          </a:p>
+          <a:p>
+            <a:pPr>
+              <a:defRPr b="1" sz="1300">
+                <a:solidFill>
+                  <a:srgbClr val="38BDF8"/>
+                </a:solidFill>
+              </a:defRPr>
+            </a:pPr>
+            <a:r>
+              <a:t>2. Primary ML Ensemble: Balanced Random Forest (100 Trees)</a:t>
+            </a:r>
+            <a:br/>
+            <a:r>
+              <a:rPr b="0" sz="1100">
+                <a:solidFill>
+                  <a:srgbClr val="94A3B8"/>
+                </a:solidFill>
+              </a:rPr>
+              <a:t>Ensemble of 100 decorrelated decision trees utilizing Gini impurity splits and balanced bootstrap resampling to penalize false negatives on rare fraud anomalies.
+</a:t>
+            </a:r>
+          </a:p>
+          <a:p>
+            <a:pPr>
+              <a:defRPr b="1" sz="1300">
+                <a:solidFill>
+                  <a:srgbClr val="38BDF8"/>
+                </a:solidFill>
+              </a:defRPr>
+            </a:pPr>
+            <a:r>
+              <a:t>3. Secondary ML Tier: Gradient Boosting &amp; Neural MLP</a:t>
+            </a:r>
+            <a:br/>
+            <a:r>
+              <a:rPr b="0" sz="1100">
+                <a:solidFill>
+                  <a:srgbClr val="94A3B8"/>
+                </a:solidFill>
+              </a:rPr>
+              <a:t>100-stage Gradient Boosting Regressor (learning rate 0.1) ensembled with multi-layer perceptron (64-32 architecture, ReLU activation) providing non-linear boundary regularization.
+</a:t>
+            </a:r>
+          </a:p>
+          <a:p>
+            <a:pPr>
+              <a:defRPr b="1" sz="1300">
+                <a:solidFill>
+                  <a:srgbClr val="38BDF8"/>
+                </a:solidFill>
+              </a:defRPr>
+            </a:pPr>
+            <a:r>
+              <a:t>4. Explainability Engine: Directional SHAP Attributions</a:t>
+            </a:r>
+            <a:br/>
+            <a:r>
+              <a:rPr b="0" sz="1100">
+                <a:solidFill>
+                  <a:srgbClr val="94A3B8"/>
+                </a:solidFill>
+              </a:rPr>
+              <a:t>Computes local feature impact scores isolating risk-increasing vs risk-reducing vectors with percentage contributions for instant forensic operator audit.
+</a:t>
+            </a:r>
+          </a:p>
+          <a:p>
+            <a:pPr>
+              <a:defRPr b="1" sz="1300">
+                <a:solidFill>
+                  <a:srgbClr val="38BDF8"/>
+                </a:solidFill>
+              </a:defRPr>
+            </a:pPr>
+            <a:r>
+              <a:t>5. Relational SQLite Persistence &amp; Sanctions Ledger</a:t>
+            </a:r>
+            <a:br/>
+            <a:r>
+              <a:rPr b="0" sz="1100">
+                <a:solidFill>
+                  <a:srgbClr val="94A3B8"/>
+                </a:solidFill>
+              </a:rPr>
+              <a:t>ACID-compliant storage in 'credit_card_fraud.db' capturing all transactions, blocked cards, audit logs, and empirical model benchmark coordinates.
+</a:t>
             </a:r>
           </a:p>
         </p:txBody>
@@ -3695,13 +5402,13 @@
         <p:spPr>
           <a:xfrm>
             <a:off x="0" y="0"/>
-            <a:ext cx="12191695" cy="1097280"/>
+            <a:ext cx="12191695" cy="6858000"/>
           </a:xfrm>
           <a:prstGeom prst="rect">
             <a:avLst/>
           </a:prstGeom>
           <a:solidFill>
-            <a:srgbClr val="0F172A"/>
+            <a:srgbClr val="060913"/>
           </a:solidFill>
           <a:ln>
             <a:noFill/>
@@ -3737,8 +5444,8 @@
         </p:nvSpPr>
         <p:spPr>
           <a:xfrm>
-            <a:off x="731520" y="137160"/>
-            <a:ext cx="10698480" cy="822960"/>
+            <a:off x="731520" y="365760"/>
+            <a:ext cx="10728655" cy="1005840"/>
           </a:xfrm>
           <a:prstGeom prst="rect">
             <a:avLst/>
@@ -3752,40 +5459,64 @@
           <a:lstStyle/>
           <a:p>
             <a:pPr>
-              <a:defRPr sz="2400" b="1">
-                <a:solidFill>
-                  <a:srgbClr val="FFFFFF"/>
-                </a:solidFill>
-              </a:defRPr>
-            </a:pPr>
-            <a:r>
-              <a:t>3. System Architecture &amp; Workflow Pipeline</a:t>
-            </a:r>
-          </a:p>
-          <a:p>
-            <a:pPr>
-              <a:defRPr sz="1100">
-                <a:solidFill>
-                  <a:srgbClr val="94A3B8"/>
-                </a:solidFill>
-              </a:defRPr>
-            </a:pPr>
-            <a:r>
-              <a:t>Academic &amp; Industrial AI Project Series  |  Project 21 of 55</a:t>
-            </a:r>
-          </a:p>
-        </p:txBody>
-      </p:sp>
-      <p:sp>
-        <p:nvSpPr>
-          <p:cNvPr id="4" name="TextBox 3"/>
+              <a:defRPr sz="1100" b="1">
+                <a:solidFill>
+                  <a:srgbClr val="F59E0B"/>
+                </a:solidFill>
+              </a:defRPr>
+            </a:pPr>
+            <a:r>
+              <a:t>FINTECH MACHINE LEARNING &amp; CYBER RISK • PROJECT-021</a:t>
+            </a:r>
+          </a:p>
+          <a:p>
+            <a:pPr>
+              <a:defRPr sz="2200" b="1">
+                <a:solidFill>
+                  <a:srgbClr val="F8FAFC"/>
+                </a:solidFill>
+              </a:defRPr>
+            </a:pPr>
+            <a:r>
+              <a:t>Real-Time Telematics Stream &amp; Transaction Monitoring HUD</a:t>
+            </a:r>
+          </a:p>
+        </p:txBody>
+      </p:sp>
+      <p:pic>
+        <p:nvPicPr>
+          <p:cNvPr id="4" name="Picture 3" descr="01_realtime_telematics_stream.png"/>
+          <p:cNvPicPr>
+            <a:picLocks noChangeAspect="1"/>
+          </p:cNvPicPr>
+          <p:nvPr/>
+        </p:nvPicPr>
+        <p:blipFill>
+          <a:blip r:embed="rId2"/>
+          <a:stretch>
+            <a:fillRect/>
+          </a:stretch>
+        </p:blipFill>
+        <p:spPr>
+          <a:xfrm>
+            <a:off x="731520" y="1463040"/>
+            <a:ext cx="6858000" cy="4754880"/>
+          </a:xfrm>
+          <a:prstGeom prst="rect">
+            <a:avLst/>
+          </a:prstGeom>
+        </p:spPr>
+      </p:pic>
+      <p:sp>
+        <p:nvSpPr>
+          <p:cNvPr id="5" name="TextBox 4"/>
           <p:cNvSpPr txBox="1"/>
           <p:nvPr/>
         </p:nvSpPr>
         <p:spPr>
           <a:xfrm>
-            <a:off x="731520" y="1371600"/>
-            <a:ext cx="10698480" cy="5029200"/>
+            <a:off x="7863840" y="1463040"/>
+            <a:ext cx="3657600" cy="4754880"/>
           </a:xfrm>
           <a:prstGeom prst="rect">
             <a:avLst/>
@@ -3799,137 +5530,86 @@
           <a:lstStyle/>
           <a:p>
             <a:pPr>
-              <a:spcBef>
-                <a:spcPts val="800"/>
-              </a:spcBef>
-              <a:defRPr sz="1500" b="1">
-                <a:solidFill>
-                  <a:srgbClr val="2563EB"/>
-                </a:solidFill>
-              </a:defRPr>
-            </a:pPr>
-            <a:r>
-              <a:t>[1] Ingestion Layer</a:t>
-            </a:r>
-          </a:p>
-          <a:p>
-            <a:pPr>
-              <a:defRPr sz="1300">
-                <a:solidFill>
-                  <a:srgbClr val="475569"/>
-                </a:solidFill>
-              </a:defRPr>
-            </a:pPr>
-            <a:r>
-              <a:t>Raw telemetry, video feeds, or structured tabular features ingested via secure endpoints.</a:t>
-            </a:r>
-          </a:p>
-          <a:p>
-            <a:pPr>
-              <a:spcBef>
-                <a:spcPts val="800"/>
-              </a:spcBef>
-              <a:defRPr sz="1500" b="1">
-                <a:solidFill>
-                  <a:srgbClr val="2563EB"/>
-                </a:solidFill>
-              </a:defRPr>
-            </a:pPr>
-            <a:r>
-              <a:t>[2] Preprocessing &amp; Normalization</a:t>
-            </a:r>
-          </a:p>
-          <a:p>
-            <a:pPr>
-              <a:defRPr sz="1300">
-                <a:solidFill>
-                  <a:srgbClr val="475569"/>
-                </a:solidFill>
-              </a:defRPr>
-            </a:pPr>
-            <a:r>
-              <a:t>Feature scaling, missing value imputation, winsorization, and tensor reshaping.</a:t>
-            </a:r>
-          </a:p>
-          <a:p>
-            <a:pPr>
-              <a:spcBef>
-                <a:spcPts val="800"/>
-              </a:spcBef>
-              <a:defRPr sz="1500" b="1">
-                <a:solidFill>
-                  <a:srgbClr val="2563EB"/>
-                </a:solidFill>
-              </a:defRPr>
-            </a:pPr>
-            <a:r>
-              <a:t>[3] Deep Neural Inference Engine</a:t>
-            </a:r>
-          </a:p>
-          <a:p>
-            <a:pPr>
-              <a:defRPr sz="1300">
-                <a:solidFill>
-                  <a:srgbClr val="475569"/>
-                </a:solidFill>
-              </a:defRPr>
-            </a:pPr>
-            <a:r>
-              <a:t>Optimized model evaluating representations with GPU/MPS/CPU acceleration.</a:t>
-            </a:r>
-          </a:p>
-          <a:p>
-            <a:pPr>
-              <a:spcBef>
-                <a:spcPts val="800"/>
-              </a:spcBef>
-              <a:defRPr sz="1500" b="1">
-                <a:solidFill>
-                  <a:srgbClr val="2563EB"/>
-                </a:solidFill>
-              </a:defRPr>
-            </a:pPr>
-            <a:r>
-              <a:t>[4] Post-Processing &amp; Decision Support</a:t>
-            </a:r>
-          </a:p>
-          <a:p>
-            <a:pPr>
-              <a:defRPr sz="1300">
-                <a:solidFill>
-                  <a:srgbClr val="475569"/>
-                </a:solidFill>
-              </a:defRPr>
-            </a:pPr>
-            <a:r>
-              <a:t>Threshold calibration, confidence scoring, classification/regression output formatting.</a:t>
-            </a:r>
-          </a:p>
-          <a:p>
-            <a:pPr>
-              <a:spcBef>
-                <a:spcPts val="800"/>
-              </a:spcBef>
-              <a:defRPr sz="1500" b="1">
-                <a:solidFill>
-                  <a:srgbClr val="2563EB"/>
-                </a:solidFill>
-              </a:defRPr>
-            </a:pPr>
-            <a:r>
-              <a:t>[5] Visualization &amp; Persistence</a:t>
-            </a:r>
-          </a:p>
-          <a:p>
-            <a:pPr>
-              <a:defRPr sz="1300">
-                <a:solidFill>
-                  <a:srgbClr val="475569"/>
-                </a:solidFill>
-              </a:defRPr>
-            </a:pPr>
-            <a:r>
-              <a:t>Interactive UI dashboard rendering metrics and SQLite/PostgreSQL audit logging.</a:t>
+              <a:defRPr b="1" sz="1500">
+                <a:solidFill>
+                  <a:srgbClr val="F8FAFC"/>
+                </a:solidFill>
+              </a:defRPr>
+            </a:pPr>
+            <a:r>
+              <a:t>Telematics Stream HUD</a:t>
+            </a:r>
+          </a:p>
+          <a:p>
+            <a:pPr>
+              <a:defRPr sz="1100">
+                <a:solidFill>
+                  <a:srgbClr val="38BDF8"/>
+                </a:solidFill>
+              </a:defRPr>
+            </a:pPr>
+            <a:r>
+              <a:t>✔ Live transaction ledger with card ID, merchant &amp; amount</a:t>
+            </a:r>
+          </a:p>
+          <a:p>
+            <a:pPr>
+              <a:defRPr sz="1100">
+                <a:solidFill>
+                  <a:srgbClr val="38BDF8"/>
+                </a:solidFill>
+              </a:defRPr>
+            </a:pPr>
+            <a:r>
+              <a:t>✔ Radial Risk Gauge visualizing transaction probability</a:t>
+            </a:r>
+          </a:p>
+          <a:p>
+            <a:pPr>
+              <a:defRPr sz="1100">
+                <a:solidFill>
+                  <a:srgbClr val="38BDF8"/>
+                </a:solidFill>
+              </a:defRPr>
+            </a:pPr>
+            <a:r>
+              <a:t>✔ KPI Cards: Total volume, fraud rate, critical alerts</a:t>
+            </a:r>
+          </a:p>
+          <a:p>
+            <a:pPr>
+              <a:defRPr sz="1100">
+                <a:solidFill>
+                  <a:srgbClr val="38BDF8"/>
+                </a:solidFill>
+              </a:defRPr>
+            </a:pPr>
+            <a:r>
+              <a:t>✔ Stream toggle: pause, resume, and real-time feed</a:t>
+            </a:r>
+          </a:p>
+          <a:p>
+            <a:pPr>
+              <a:defRPr sz="1100">
+                <a:solidFill>
+                  <a:srgbClr val="38BDF8"/>
+                </a:solidFill>
+              </a:defRPr>
+            </a:pPr>
+            <a:r>
+              <a:t>✔ Instant Fraud Injection button for live defense drills</a:t>
+            </a:r>
+          </a:p>
+          <a:p>
+            <a:pPr>
+              <a:defRPr sz="1100">
+                <a:solidFill>
+                  <a:srgbClr val="38BDF8"/>
+                </a:solidFill>
+              </a:defRPr>
+            </a:pPr>
+            <a:r>
+              <a:t>✔ Color-coded threat badges (APPROVED, REVIEW, DECLINED)</a:t>
             </a:r>
           </a:p>
         </p:txBody>
@@ -3961,13 +5641,13 @@
         <p:spPr>
           <a:xfrm>
             <a:off x="0" y="0"/>
-            <a:ext cx="12191695" cy="1097280"/>
+            <a:ext cx="12191695" cy="6858000"/>
           </a:xfrm>
           <a:prstGeom prst="rect">
             <a:avLst/>
           </a:prstGeom>
           <a:solidFill>
-            <a:srgbClr val="0F172A"/>
+            <a:srgbClr val="060913"/>
           </a:solidFill>
           <a:ln>
             <a:noFill/>
@@ -4003,8 +5683,8 @@
         </p:nvSpPr>
         <p:spPr>
           <a:xfrm>
-            <a:off x="731520" y="137160"/>
-            <a:ext cx="10698480" cy="822960"/>
+            <a:off x="731520" y="365760"/>
+            <a:ext cx="10728655" cy="1005840"/>
           </a:xfrm>
           <a:prstGeom prst="rect">
             <a:avLst/>
@@ -4018,40 +5698,64 @@
           <a:lstStyle/>
           <a:p>
             <a:pPr>
-              <a:defRPr sz="2400" b="1">
-                <a:solidFill>
-                  <a:srgbClr val="FFFFFF"/>
-                </a:solidFill>
-              </a:defRPr>
-            </a:pPr>
-            <a:r>
-              <a:t>4. Deep Learning &amp; ML Methodology</a:t>
-            </a:r>
-          </a:p>
-          <a:p>
-            <a:pPr>
-              <a:defRPr sz="1100">
-                <a:solidFill>
-                  <a:srgbClr val="94A3B8"/>
-                </a:solidFill>
-              </a:defRPr>
-            </a:pPr>
-            <a:r>
-              <a:t>Academic &amp; Industrial AI Project Series  |  Project 21 of 55</a:t>
-            </a:r>
-          </a:p>
-        </p:txBody>
-      </p:sp>
-      <p:sp>
-        <p:nvSpPr>
-          <p:cNvPr id="4" name="TextBox 3"/>
+              <a:defRPr sz="1100" b="1">
+                <a:solidFill>
+                  <a:srgbClr val="F59E0B"/>
+                </a:solidFill>
+              </a:defRPr>
+            </a:pPr>
+            <a:r>
+              <a:t>FINTECH MACHINE LEARNING &amp; CYBER RISK • PROJECT-021</a:t>
+            </a:r>
+          </a:p>
+          <a:p>
+            <a:pPr>
+              <a:defRPr sz="2200" b="1">
+                <a:solidFill>
+                  <a:srgbClr val="F8FAFC"/>
+                </a:solidFill>
+              </a:defRPr>
+            </a:pPr>
+            <a:r>
+              <a:t>Instant Fraud Interdiction &amp; Automated Account Sanctions</a:t>
+            </a:r>
+          </a:p>
+        </p:txBody>
+      </p:sp>
+      <p:pic>
+        <p:nvPicPr>
+          <p:cNvPr id="4" name="Picture 3" descr="02_fraud_alert_critical_interdiction.png"/>
+          <p:cNvPicPr>
+            <a:picLocks noChangeAspect="1"/>
+          </p:cNvPicPr>
+          <p:nvPr/>
+        </p:nvPicPr>
+        <p:blipFill>
+          <a:blip r:embed="rId2"/>
+          <a:stretch>
+            <a:fillRect/>
+          </a:stretch>
+        </p:blipFill>
+        <p:spPr>
+          <a:xfrm>
+            <a:off x="731520" y="1463040"/>
+            <a:ext cx="6858000" cy="4754880"/>
+          </a:xfrm>
+          <a:prstGeom prst="rect">
+            <a:avLst/>
+          </a:prstGeom>
+        </p:spPr>
+      </p:pic>
+      <p:sp>
+        <p:nvSpPr>
+          <p:cNvPr id="5" name="TextBox 4"/>
           <p:cNvSpPr txBox="1"/>
           <p:nvPr/>
         </p:nvSpPr>
         <p:spPr>
           <a:xfrm>
-            <a:off x="731520" y="1371600"/>
-            <a:ext cx="10698480" cy="5029200"/>
+            <a:off x="7863840" y="1463040"/>
+            <a:ext cx="3657600" cy="4754880"/>
           </a:xfrm>
           <a:prstGeom prst="rect">
             <a:avLst/>
@@ -4065,110 +5769,98 @@
           <a:lstStyle/>
           <a:p>
             <a:pPr>
-              <a:spcBef>
-                <a:spcPts val="800"/>
-              </a:spcBef>
-              <a:defRPr sz="1500" b="1">
-                <a:solidFill>
-                  <a:srgbClr val="0F172A"/>
-                </a:solidFill>
-              </a:defRPr>
-            </a:pPr>
-            <a:r>
-              <a:t>• Feature Engineering &amp; Dimensionality Alignment</a:t>
-            </a:r>
-          </a:p>
-          <a:p>
-            <a:pPr>
-              <a:defRPr sz="1300">
-                <a:solidFill>
-                  <a:srgbClr val="475569"/>
-                </a:solidFill>
-              </a:defRPr>
-            </a:pPr>
-            <a:r>
-              <a:t>Domain-specific feature extraction, temporal windowing, and embedding vectors.</a:t>
-            </a:r>
-          </a:p>
-          <a:p>
-            <a:pPr>
-              <a:spcBef>
-                <a:spcPts val="800"/>
-              </a:spcBef>
-              <a:defRPr sz="1500" b="1">
-                <a:solidFill>
-                  <a:srgbClr val="0F172A"/>
-                </a:solidFill>
-              </a:defRPr>
-            </a:pPr>
-            <a:r>
-              <a:t>• Model Family &amp; Optimization</a:t>
-            </a:r>
-          </a:p>
-          <a:p>
-            <a:pPr>
-              <a:defRPr sz="1300">
-                <a:solidFill>
-                  <a:srgbClr val="475569"/>
-                </a:solidFill>
-              </a:defRPr>
-            </a:pPr>
-            <a:r>
-              <a:t>Ensemble gradient boosting or deep neural networks trained with AdamW and adaptive LR scheduling.</a:t>
-            </a:r>
-          </a:p>
-          <a:p>
-            <a:pPr>
-              <a:spcBef>
-                <a:spcPts val="800"/>
-              </a:spcBef>
-              <a:defRPr sz="1500" b="1">
-                <a:solidFill>
-                  <a:srgbClr val="0F172A"/>
-                </a:solidFill>
-              </a:defRPr>
-            </a:pPr>
-            <a:r>
-              <a:t>• Overfitting Mitigation</a:t>
-            </a:r>
-          </a:p>
-          <a:p>
-            <a:pPr>
-              <a:defRPr sz="1300">
-                <a:solidFill>
-                  <a:srgbClr val="475569"/>
-                </a:solidFill>
-              </a:defRPr>
-            </a:pPr>
-            <a:r>
-              <a:t>Stratified k-fold cross-validation, dropout layers, early stopping, and data augmentation.</a:t>
-            </a:r>
-          </a:p>
-          <a:p>
-            <a:pPr>
-              <a:spcBef>
-                <a:spcPts val="800"/>
-              </a:spcBef>
-              <a:defRPr sz="1500" b="1">
-                <a:solidFill>
-                  <a:srgbClr val="0F172A"/>
-                </a:solidFill>
-              </a:defRPr>
-            </a:pPr>
-            <a:r>
-              <a:t>• Explainability &amp; Auditability</a:t>
-            </a:r>
-          </a:p>
-          <a:p>
-            <a:pPr>
-              <a:defRPr sz="1300">
-                <a:solidFill>
-                  <a:srgbClr val="475569"/>
-                </a:solidFill>
-              </a:defRPr>
-            </a:pPr>
-            <a:r>
-              <a:t>Confidence scores and feature importance attributions for high-stakes decisions.</a:t>
+              <a:defRPr b="1" sz="1500">
+                <a:solidFill>
+                  <a:srgbClr val="F43F5E"/>
+                </a:solidFill>
+              </a:defRPr>
+            </a:pPr>
+            <a:r>
+              <a:t>Critical Interdiction Case</a:t>
+            </a:r>
+          </a:p>
+          <a:p>
+            <a:pPr>
+              <a:defRPr sz="1100">
+                <a:solidFill>
+                  <a:srgbClr val="F8FAFC"/>
+                </a:solidFill>
+              </a:defRPr>
+            </a:pPr>
+            <a:r>
+              <a:t>▶ Merchant: Midnight High-Value Jewelry Wire ($4,890.00)</a:t>
+            </a:r>
+          </a:p>
+          <a:p>
+            <a:pPr>
+              <a:defRPr sz="1100">
+                <a:solidFill>
+                  <a:srgbClr val="F8FAFC"/>
+                </a:solidFill>
+              </a:defRPr>
+            </a:pPr>
+            <a:r>
+              <a:t>▶ Risk Score: 96.5% certainty of illicit activity</a:t>
+            </a:r>
+          </a:p>
+          <a:p>
+            <a:pPr>
+              <a:defRPr sz="1100">
+                <a:solidFill>
+                  <a:srgbClr val="F8FAFC"/>
+                </a:solidFill>
+              </a:defRPr>
+            </a:pPr>
+            <a:r>
+              <a:t>▶ Decision: DECLINED (Instant Terminal Interlock)</a:t>
+            </a:r>
+          </a:p>
+          <a:p>
+            <a:pPr>
+              <a:defRPr sz="1100">
+                <a:solidFill>
+                  <a:srgbClr val="F8FAFC"/>
+                </a:solidFill>
+              </a:defRPr>
+            </a:pPr>
+            <a:r>
+              <a:t>▶ Risk Level: CRITICAL THREAT tier</a:t>
+            </a:r>
+          </a:p>
+          <a:p>
+            <a:pPr>
+              <a:defRPr sz="1100">
+                <a:solidFill>
+                  <a:srgbClr val="F8FAFC"/>
+                </a:solidFill>
+              </a:defRPr>
+            </a:pPr>
+            <a:r>
+              <a:t>▶ Action: BLOCK_IMMEDIATE with automatic card freeze</a:t>
+            </a:r>
+          </a:p>
+          <a:p>
+            <a:pPr>
+              <a:defRPr sz="1100">
+                <a:solidFill>
+                  <a:srgbClr val="F8FAFC"/>
+                </a:solidFill>
+              </a:defRPr>
+            </a:pPr>
+            <a:r>
+              <a:t>▶ Acoustic and visual alert sirens triggered on console</a:t>
+            </a:r>
+          </a:p>
+          <a:p>
+            <a:pPr>
+              <a:defRPr sz="1100">
+                <a:solidFill>
+                  <a:srgbClr val="F8FAFC"/>
+                </a:solidFill>
+              </a:defRPr>
+            </a:pPr>
+            <a:r>
+              <a:t>▶ Persisted into SQLite audit ledger with operator ID</a:t>
             </a:r>
           </a:p>
         </p:txBody>
@@ -4200,13 +5892,13 @@
         <p:spPr>
           <a:xfrm>
             <a:off x="0" y="0"/>
-            <a:ext cx="12191695" cy="1097280"/>
+            <a:ext cx="12191695" cy="6858000"/>
           </a:xfrm>
           <a:prstGeom prst="rect">
             <a:avLst/>
           </a:prstGeom>
           <a:solidFill>
-            <a:srgbClr val="0F172A"/>
+            <a:srgbClr val="060913"/>
           </a:solidFill>
           <a:ln>
             <a:noFill/>
@@ -4242,8 +5934,8 @@
         </p:nvSpPr>
         <p:spPr>
           <a:xfrm>
-            <a:off x="731520" y="137160"/>
-            <a:ext cx="10698480" cy="822960"/>
+            <a:off x="731520" y="365760"/>
+            <a:ext cx="10728655" cy="1005840"/>
           </a:xfrm>
           <a:prstGeom prst="rect">
             <a:avLst/>
@@ -4257,26 +5949,26 @@
           <a:lstStyle/>
           <a:p>
             <a:pPr>
-              <a:defRPr sz="2400" b="1">
-                <a:solidFill>
-                  <a:srgbClr val="FFFFFF"/>
-                </a:solidFill>
-              </a:defRPr>
-            </a:pPr>
-            <a:r>
-              <a:t>5. Experimental Results &amp; Performance Benchmarks</a:t>
-            </a:r>
-          </a:p>
-          <a:p>
-            <a:pPr>
-              <a:defRPr sz="1100">
-                <a:solidFill>
-                  <a:srgbClr val="94A3B8"/>
-                </a:solidFill>
-              </a:defRPr>
-            </a:pPr>
-            <a:r>
-              <a:t>Academic &amp; Industrial AI Project Series  |  Project 21 of 55</a:t>
+              <a:defRPr sz="1100" b="1">
+                <a:solidFill>
+                  <a:srgbClr val="F59E0B"/>
+                </a:solidFill>
+              </a:defRPr>
+            </a:pPr>
+            <a:r>
+              <a:t>FINTECH MACHINE LEARNING &amp; CYBER RISK • PROJECT-021</a:t>
+            </a:r>
+          </a:p>
+          <a:p>
+            <a:pPr>
+              <a:defRPr sz="2200" b="1">
+                <a:solidFill>
+                  <a:srgbClr val="F8FAFC"/>
+                </a:solidFill>
+              </a:defRPr>
+            </a:pPr>
+            <a:r>
+              <a:t>Multi-Model Ensemble Formulation &amp; Cost-Sensitive Learning</a:t>
             </a:r>
           </a:p>
         </p:txBody>
@@ -4289,8 +5981,8 @@
         </p:nvSpPr>
         <p:spPr>
           <a:xfrm>
-            <a:off x="731520" y="1371600"/>
-            <a:ext cx="10698480" cy="5029200"/>
+            <a:off x="731520" y="1463040"/>
+            <a:ext cx="10728655" cy="4754880"/>
           </a:xfrm>
           <a:prstGeom prst="rect">
             <a:avLst/>
@@ -4304,62 +5996,90 @@
           <a:lstStyle/>
           <a:p>
             <a:pPr>
-              <a:spcBef>
-                <a:spcPts val="1200"/>
-              </a:spcBef>
-              <a:defRPr sz="1500" b="1">
-                <a:solidFill>
-                  <a:srgbClr val="10B981"/>
-                </a:solidFill>
-              </a:defRPr>
-            </a:pPr>
-            <a:r>
-              <a:t>★ Validation Accuracy / Score: Achieved 94.8% on independent validation test holdout partitions.</a:t>
-            </a:r>
-          </a:p>
-          <a:p>
-            <a:pPr>
-              <a:spcBef>
-                <a:spcPts val="1200"/>
-              </a:spcBef>
-              <a:defRPr sz="1500" b="1">
-                <a:solidFill>
-                  <a:srgbClr val="10B981"/>
-                </a:solidFill>
-              </a:defRPr>
-            </a:pPr>
-            <a:r>
-              <a:t>★ F1-Score / Macro Precision: Balanced metric of 0.932 across positive and negative classification targets.</a:t>
-            </a:r>
-          </a:p>
-          <a:p>
-            <a:pPr>
-              <a:spcBef>
-                <a:spcPts val="1200"/>
-              </a:spcBef>
-              <a:defRPr sz="1500" b="1">
-                <a:solidFill>
-                  <a:srgbClr val="10B981"/>
-                </a:solidFill>
-              </a:defRPr>
-            </a:pPr>
-            <a:r>
-              <a:t>★ Inference Latency Profile: Median latency of 18.4 ms per inference query on edge CPU hardware.</a:t>
-            </a:r>
-          </a:p>
-          <a:p>
-            <a:pPr>
-              <a:spcBef>
-                <a:spcPts val="1200"/>
-              </a:spcBef>
-              <a:defRPr sz="1500" b="1">
-                <a:solidFill>
-                  <a:srgbClr val="10B981"/>
-                </a:solidFill>
-              </a:defRPr>
-            </a:pPr>
-            <a:r>
-              <a:t>★ False Positive Rate (FPR): Maintained below 2.8%, satisfying stringent operational false alarm constraints.</a:t>
+              <a:defRPr b="1" sz="1300">
+                <a:solidFill>
+                  <a:srgbClr val="F59E0B"/>
+                </a:solidFill>
+              </a:defRPr>
+            </a:pPr>
+            <a:r>
+              <a:t>• Balanced Random Forest Formulation</a:t>
+            </a:r>
+            <a:br/>
+            <a:r>
+              <a:rPr b="0" sz="1100">
+                <a:solidFill>
+                  <a:srgbClr val="94A3B8"/>
+                </a:solidFill>
+              </a:rPr>
+              <a:t>Given training set D with imbalanced classes, bootstrap samples S_b are drawn with balanced class weights w_c = N / (2 * N_c). Individual decision trees minimize Gini impurity: Gini(t) = 1 - sum_{i=1}^C p(i|t)^2. Aggregated probability P_RF(x) = (1/B) sum_{b=1}^B T_b(x).
+</a:t>
+            </a:r>
+          </a:p>
+          <a:p>
+            <a:pPr>
+              <a:defRPr b="1" sz="1300">
+                <a:solidFill>
+                  <a:srgbClr val="F59E0B"/>
+                </a:solidFill>
+              </a:defRPr>
+            </a:pPr>
+            <a:r>
+              <a:t>• Gradient Boosting Decision Trees (GBM)</a:t>
+            </a:r>
+            <a:br/>
+            <a:r>
+              <a:rPr b="0" sz="1100">
+                <a:solidFill>
+                  <a:srgbClr val="94A3B8"/>
+                </a:solidFill>
+              </a:rPr>
+              <a:t>Iterative boosting sequentially minimizes binomial log-likelihood loss L(y, F(x)) = log(1 + exp(-2 y F(x))). Shrinkage learning rate eta = 0.1 prevents overfitting on anomalous outliers.
+</a:t>
+            </a:r>
+          </a:p>
+          <a:p>
+            <a:pPr>
+              <a:defRPr b="1" sz="1300">
+                <a:solidFill>
+                  <a:srgbClr val="F59E0B"/>
+                </a:solidFill>
+              </a:defRPr>
+            </a:pPr>
+            <a:r>
+              <a:t>• Multi-Layer Perceptron (Neural MLP)</a:t>
+            </a:r>
+            <a:br/>
+            <a:r>
+              <a:rPr b="0" sz="1100">
+                <a:solidFill>
+                  <a:srgbClr val="94A3B8"/>
+                </a:solidFill>
+              </a:rPr>
+              <a:t>Dense feedforward architecture: Input (30) -&gt; Dense(64, ReLU) -&gt; Dropout(0.2) -&gt; Dense(32, ReLU) -&gt; Output(Sigmoid). Optimized via Adam (lr=0.001) with early stopping.
+</a:t>
+            </a:r>
+          </a:p>
+          <a:p>
+            <a:pPr>
+              <a:defRPr b="1" sz="1300">
+                <a:solidFill>
+                  <a:srgbClr val="F59E0B"/>
+                </a:solidFill>
+              </a:defRPr>
+            </a:pPr>
+            <a:r>
+              <a:t>• Weighted Ensemble Inference</a:t>
+            </a:r>
+            <a:br/>
+            <a:r>
+              <a:rPr b="0" sz="1100">
+                <a:solidFill>
+                  <a:srgbClr val="94A3B8"/>
+                </a:solidFill>
+              </a:rPr>
+              <a:t>P_ensemble(x) = alpha * P_RF(x) + beta * P_GBM(x) + gamma * P_MLP(x), calibrated with alpha = 0.70, beta = 0.30 to optimize Area Under the Precision-Recall Curve (PR-AUC).
+</a:t>
             </a:r>
           </a:p>
         </p:txBody>
@@ -4391,13 +6111,13 @@
         <p:spPr>
           <a:xfrm>
             <a:off x="0" y="0"/>
-            <a:ext cx="12191695" cy="1097280"/>
+            <a:ext cx="12191695" cy="6858000"/>
           </a:xfrm>
           <a:prstGeom prst="rect">
             <a:avLst/>
           </a:prstGeom>
           <a:solidFill>
-            <a:srgbClr val="0F172A"/>
+            <a:srgbClr val="060913"/>
           </a:solidFill>
           <a:ln>
             <a:noFill/>
@@ -4433,8 +6153,8 @@
         </p:nvSpPr>
         <p:spPr>
           <a:xfrm>
-            <a:off x="731520" y="137160"/>
-            <a:ext cx="10698480" cy="822960"/>
+            <a:off x="731520" y="365760"/>
+            <a:ext cx="10728655" cy="1005840"/>
           </a:xfrm>
           <a:prstGeom prst="rect">
             <a:avLst/>
@@ -4448,40 +6168,64 @@
           <a:lstStyle/>
           <a:p>
             <a:pPr>
-              <a:defRPr sz="2400" b="1">
-                <a:solidFill>
-                  <a:srgbClr val="FFFFFF"/>
-                </a:solidFill>
-              </a:defRPr>
-            </a:pPr>
-            <a:r>
-              <a:t>6. Technology Stack &amp; Production Deployment</a:t>
-            </a:r>
-          </a:p>
-          <a:p>
-            <a:pPr>
-              <a:defRPr sz="1100">
-                <a:solidFill>
-                  <a:srgbClr val="94A3B8"/>
-                </a:solidFill>
-              </a:defRPr>
-            </a:pPr>
-            <a:r>
-              <a:t>Academic &amp; Industrial AI Project Series  |  Project 21 of 55</a:t>
-            </a:r>
-          </a:p>
-        </p:txBody>
-      </p:sp>
-      <p:sp>
-        <p:nvSpPr>
-          <p:cNvPr id="4" name="TextBox 3"/>
+              <a:defRPr sz="1100" b="1">
+                <a:solidFill>
+                  <a:srgbClr val="F59E0B"/>
+                </a:solidFill>
+              </a:defRPr>
+            </a:pPr>
+            <a:r>
+              <a:t>FINTECH MACHINE LEARNING &amp; CYBER RISK • PROJECT-021</a:t>
+            </a:r>
+          </a:p>
+          <a:p>
+            <a:pPr>
+              <a:defRPr sz="2200" b="1">
+                <a:solidFill>
+                  <a:srgbClr val="F8FAFC"/>
+                </a:solidFill>
+              </a:defRPr>
+            </a:pPr>
+            <a:r>
+              <a:t>Explainable AI (XAI): Directional SHAP Feature Attributions</a:t>
+            </a:r>
+          </a:p>
+        </p:txBody>
+      </p:sp>
+      <p:pic>
+        <p:nvPicPr>
+          <p:cNvPr id="4" name="Picture 3" descr="03_forensic_inspector_shap_explainability.png"/>
+          <p:cNvPicPr>
+            <a:picLocks noChangeAspect="1"/>
+          </p:cNvPicPr>
+          <p:nvPr/>
+        </p:nvPicPr>
+        <p:blipFill>
+          <a:blip r:embed="rId2"/>
+          <a:stretch>
+            <a:fillRect/>
+          </a:stretch>
+        </p:blipFill>
+        <p:spPr>
+          <a:xfrm>
+            <a:off x="731520" y="1463040"/>
+            <a:ext cx="6858000" cy="4754880"/>
+          </a:xfrm>
+          <a:prstGeom prst="rect">
+            <a:avLst/>
+          </a:prstGeom>
+        </p:spPr>
+      </p:pic>
+      <p:sp>
+        <p:nvSpPr>
+          <p:cNvPr id="5" name="TextBox 4"/>
           <p:cNvSpPr txBox="1"/>
           <p:nvPr/>
         </p:nvSpPr>
         <p:spPr>
           <a:xfrm>
-            <a:off x="731520" y="1371600"/>
-            <a:ext cx="10698480" cy="5029200"/>
+            <a:off x="7863840" y="1463040"/>
+            <a:ext cx="3657600" cy="4754880"/>
           </a:xfrm>
           <a:prstGeom prst="rect">
             <a:avLst/>
@@ -4495,110 +6239,86 @@
           <a:lstStyle/>
           <a:p>
             <a:pPr>
-              <a:spcBef>
-                <a:spcPts val="800"/>
-              </a:spcBef>
-              <a:defRPr sz="1500" b="1">
-                <a:solidFill>
-                  <a:srgbClr val="1E3A8A"/>
-                </a:solidFill>
-              </a:defRPr>
-            </a:pPr>
-            <a:r>
-              <a:t>⚙ Core Machine Learning Framework</a:t>
-            </a:r>
-          </a:p>
-          <a:p>
-            <a:pPr>
-              <a:defRPr sz="1300">
-                <a:solidFill>
-                  <a:srgbClr val="475569"/>
-                </a:solidFill>
-              </a:defRPr>
-            </a:pPr>
-            <a:r>
-              <a:t>PyTorch 2.0+ / Scikit-learn / HuggingFace Transformers / OpenCV</a:t>
-            </a:r>
-          </a:p>
-          <a:p>
-            <a:pPr>
-              <a:spcBef>
-                <a:spcPts val="800"/>
-              </a:spcBef>
-              <a:defRPr sz="1500" b="1">
-                <a:solidFill>
-                  <a:srgbClr val="1E3A8A"/>
-                </a:solidFill>
-              </a:defRPr>
-            </a:pPr>
-            <a:r>
-              <a:t>⚙ Asynchronous REST Backend</a:t>
-            </a:r>
-          </a:p>
-          <a:p>
-            <a:pPr>
-              <a:defRPr sz="1300">
-                <a:solidFill>
-                  <a:srgbClr val="475569"/>
-                </a:solidFill>
-              </a:defRPr>
-            </a:pPr>
-            <a:r>
-              <a:t>FastAPI / Uvicorn ASGI Server / Pydantic V2 Type Safety</a:t>
-            </a:r>
-          </a:p>
-          <a:p>
-            <a:pPr>
-              <a:spcBef>
-                <a:spcPts val="800"/>
-              </a:spcBef>
-              <a:defRPr sz="1500" b="1">
-                <a:solidFill>
-                  <a:srgbClr val="1E3A8A"/>
-                </a:solidFill>
-              </a:defRPr>
-            </a:pPr>
-            <a:r>
-              <a:t>⚙ Data Persistence &amp; Storage</a:t>
-            </a:r>
-          </a:p>
-          <a:p>
-            <a:pPr>
-              <a:defRPr sz="1300">
-                <a:solidFill>
-                  <a:srgbClr val="475569"/>
-                </a:solidFill>
-              </a:defRPr>
-            </a:pPr>
-            <a:r>
-              <a:t>SQLite / PostgreSQL with transactional integrity &amp; audit trail</a:t>
-            </a:r>
-          </a:p>
-          <a:p>
-            <a:pPr>
-              <a:spcBef>
-                <a:spcPts val="800"/>
-              </a:spcBef>
-              <a:defRPr sz="1500" b="1">
-                <a:solidFill>
-                  <a:srgbClr val="1E3A8A"/>
-                </a:solidFill>
-              </a:defRPr>
-            </a:pPr>
-            <a:r>
-              <a:t>⚙ Interactive Frontend Layer</a:t>
-            </a:r>
-          </a:p>
-          <a:p>
-            <a:pPr>
-              <a:defRPr sz="1300">
-                <a:solidFill>
-                  <a:srgbClr val="475569"/>
-                </a:solidFill>
-              </a:defRPr>
-            </a:pPr>
-            <a:r>
-              <a:t>Modern Responsive Web Portal (HTML5, Tailwind/CSS, JavaScript ES6+)</a:t>
+              <a:defRPr b="1" sz="1500">
+                <a:solidFill>
+                  <a:srgbClr val="38BDF8"/>
+                </a:solidFill>
+              </a:defRPr>
+            </a:pPr>
+            <a:r>
+              <a:t>SHAP Explainability</a:t>
+            </a:r>
+          </a:p>
+          <a:p>
+            <a:pPr>
+              <a:defRPr sz="1100">
+                <a:solidFill>
+                  <a:srgbClr val="94A3B8"/>
+                </a:solidFill>
+              </a:defRPr>
+            </a:pPr>
+            <a:r>
+              <a:t>✔ Horizontal waterfall chart decomposing decision drivers</a:t>
+            </a:r>
+          </a:p>
+          <a:p>
+            <a:pPr>
+              <a:defRPr sz="1100">
+                <a:solidFill>
+                  <a:srgbClr val="94A3B8"/>
+                </a:solidFill>
+              </a:defRPr>
+            </a:pPr>
+            <a:r>
+              <a:t>✔ V14: Severe negative deviation (-5.85) adds +32% fraud risk</a:t>
+            </a:r>
+          </a:p>
+          <a:p>
+            <a:pPr>
+              <a:defRPr sz="1100">
+                <a:solidFill>
+                  <a:srgbClr val="94A3B8"/>
+                </a:solidFill>
+              </a:defRPr>
+            </a:pPr>
+            <a:r>
+              <a:t>✔ V4: Elevated positive value (+4.65) adds +28% fraud risk</a:t>
+            </a:r>
+          </a:p>
+          <a:p>
+            <a:pPr>
+              <a:defRPr sz="1100">
+                <a:solidFill>
+                  <a:srgbClr val="94A3B8"/>
+                </a:solidFill>
+              </a:defRPr>
+            </a:pPr>
+            <a:r>
+              <a:t>✔ Amount: High transaction amount ($4,890) adds +18% risk</a:t>
+            </a:r>
+          </a:p>
+          <a:p>
+            <a:pPr>
+              <a:defRPr sz="1100">
+                <a:solidFill>
+                  <a:srgbClr val="94A3B8"/>
+                </a:solidFill>
+              </a:defRPr>
+            </a:pPr>
+            <a:r>
+              <a:t>✔ V12 &amp; V10: Corroborating negative shifts add +15% risk</a:t>
+            </a:r>
+          </a:p>
+          <a:p>
+            <a:pPr>
+              <a:defRPr sz="1100">
+                <a:solidFill>
+                  <a:srgbClr val="94A3B8"/>
+                </a:solidFill>
+              </a:defRPr>
+            </a:pPr>
+            <a:r>
+              <a:t>✔ Provides compliance auditability under GDPR Article 22</a:t>
             </a:r>
           </a:p>
         </p:txBody>
@@ -4630,13 +6350,13 @@
         <p:spPr>
           <a:xfrm>
             <a:off x="0" y="0"/>
-            <a:ext cx="12191695" cy="1097280"/>
+            <a:ext cx="12191695" cy="6858000"/>
           </a:xfrm>
           <a:prstGeom prst="rect">
             <a:avLst/>
           </a:prstGeom>
           <a:solidFill>
-            <a:srgbClr val="0F172A"/>
+            <a:srgbClr val="060913"/>
           </a:solidFill>
           <a:ln>
             <a:noFill/>
@@ -4672,8 +6392,8 @@
         </p:nvSpPr>
         <p:spPr>
           <a:xfrm>
-            <a:off x="731520" y="137160"/>
-            <a:ext cx="10698480" cy="822960"/>
+            <a:off x="731520" y="365760"/>
+            <a:ext cx="10728655" cy="1005840"/>
           </a:xfrm>
           <a:prstGeom prst="rect">
             <a:avLst/>
@@ -4687,40 +6407,64 @@
           <a:lstStyle/>
           <a:p>
             <a:pPr>
-              <a:defRPr sz="2400" b="1">
-                <a:solidFill>
-                  <a:srgbClr val="FFFFFF"/>
-                </a:solidFill>
-              </a:defRPr>
-            </a:pPr>
-            <a:r>
-              <a:t>7. Conclusion &amp; Future Roadmap</a:t>
-            </a:r>
-          </a:p>
-          <a:p>
-            <a:pPr>
-              <a:defRPr sz="1100">
-                <a:solidFill>
-                  <a:srgbClr val="94A3B8"/>
-                </a:solidFill>
-              </a:defRPr>
-            </a:pPr>
-            <a:r>
-              <a:t>Academic &amp; Industrial AI Project Series  |  Project 21 of 55</a:t>
-            </a:r>
-          </a:p>
-        </p:txBody>
-      </p:sp>
-      <p:sp>
-        <p:nvSpPr>
-          <p:cNvPr id="4" name="TextBox 3"/>
+              <a:defRPr sz="1100" b="1">
+                <a:solidFill>
+                  <a:srgbClr val="F59E0B"/>
+                </a:solidFill>
+              </a:defRPr>
+            </a:pPr>
+            <a:r>
+              <a:t>FINTECH MACHINE LEARNING &amp; CYBER RISK • PROJECT-021</a:t>
+            </a:r>
+          </a:p>
+          <a:p>
+            <a:pPr>
+              <a:defRPr sz="2200" b="1">
+                <a:solidFill>
+                  <a:srgbClr val="F8FAFC"/>
+                </a:solidFill>
+              </a:defRPr>
+            </a:pPr>
+            <a:r>
+              <a:t>Empirical Benchmarks, ROC Curves &amp; Model Comparison</a:t>
+            </a:r>
+          </a:p>
+        </p:txBody>
+      </p:sp>
+      <p:pic>
+        <p:nvPicPr>
+          <p:cNvPr id="4" name="Picture 3" descr="04_model_benchmarks_roc_curves.png"/>
+          <p:cNvPicPr>
+            <a:picLocks noChangeAspect="1"/>
+          </p:cNvPicPr>
+          <p:nvPr/>
+        </p:nvPicPr>
+        <p:blipFill>
+          <a:blip r:embed="rId2"/>
+          <a:stretch>
+            <a:fillRect/>
+          </a:stretch>
+        </p:blipFill>
+        <p:spPr>
+          <a:xfrm>
+            <a:off x="731520" y="1463040"/>
+            <a:ext cx="6858000" cy="4754880"/>
+          </a:xfrm>
+          <a:prstGeom prst="rect">
+            <a:avLst/>
+          </a:prstGeom>
+        </p:spPr>
+      </p:pic>
+      <p:sp>
+        <p:nvSpPr>
+          <p:cNvPr id="5" name="TextBox 4"/>
           <p:cNvSpPr txBox="1"/>
           <p:nvPr/>
         </p:nvSpPr>
         <p:spPr>
           <a:xfrm>
-            <a:off x="731520" y="1371600"/>
-            <a:ext cx="10698480" cy="5029200"/>
+            <a:off x="7863840" y="1463040"/>
+            <a:ext cx="3657600" cy="4754880"/>
           </a:xfrm>
           <a:prstGeom prst="rect">
             <a:avLst/>
@@ -4734,83 +6478,337 @@
           <a:lstStyle/>
           <a:p>
             <a:pPr>
-              <a:spcBef>
-                <a:spcPts val="1000"/>
-              </a:spcBef>
-              <a:defRPr sz="1500" b="1">
-                <a:solidFill>
-                  <a:srgbClr val="0F172A"/>
-                </a:solidFill>
-              </a:defRPr>
-            </a:pPr>
-            <a:r>
-              <a:t>■ Project Accomplishments</a:t>
-            </a:r>
-          </a:p>
-          <a:p>
-            <a:pPr>
-              <a:defRPr sz="1300">
-                <a:solidFill>
-                  <a:srgbClr val="475569"/>
-                </a:solidFill>
-              </a:defRPr>
-            </a:pPr>
-            <a:r>
-              <a:t>Engineered a robust, end-to-end prototype validating the initial abstract with reproducible experiments.</a:t>
-            </a:r>
-          </a:p>
-          <a:p>
-            <a:pPr>
-              <a:spcBef>
-                <a:spcPts val="1000"/>
-              </a:spcBef>
-              <a:defRPr sz="1500" b="1">
-                <a:solidFill>
-                  <a:srgbClr val="0F172A"/>
-                </a:solidFill>
-              </a:defRPr>
-            </a:pPr>
-            <a:r>
-              <a:t>■ Industrial Significance</a:t>
-            </a:r>
-          </a:p>
-          <a:p>
-            <a:pPr>
-              <a:defRPr sz="1300">
-                <a:solidFill>
-                  <a:srgbClr val="475569"/>
-                </a:solidFill>
-              </a:defRPr>
-            </a:pPr>
-            <a:r>
-              <a:t>Eliminates latency and manual friction while ensuring high confidence automated decision support.</a:t>
-            </a:r>
-          </a:p>
-          <a:p>
-            <a:pPr>
-              <a:spcBef>
-                <a:spcPts val="1000"/>
-              </a:spcBef>
-              <a:defRPr sz="1500" b="1">
-                <a:solidFill>
-                  <a:srgbClr val="0F172A"/>
-                </a:solidFill>
-              </a:defRPr>
-            </a:pPr>
-            <a:r>
-              <a:t>■ Future Scope &amp; Extensions</a:t>
-            </a:r>
-          </a:p>
-          <a:p>
-            <a:pPr>
-              <a:defRPr sz="1300">
-                <a:solidFill>
-                  <a:srgbClr val="475569"/>
-                </a:solidFill>
-              </a:defRPr>
-            </a:pPr>
-            <a:r>
-              <a:t>Integration with federated edge sensors, distributed multi-tenant cloud clustering, and automated active learning.</a:t>
+              <a:defRPr b="1" sz="1500">
+                <a:solidFill>
+                  <a:srgbClr val="A855F7"/>
+                </a:solidFill>
+              </a:defRPr>
+            </a:pPr>
+            <a:r>
+              <a:t>Benchmark Metrics</a:t>
+            </a:r>
+          </a:p>
+          <a:p>
+            <a:pPr>
+              <a:defRPr sz="1100">
+                <a:solidFill>
+                  <a:srgbClr val="F8FAFC"/>
+                </a:solidFill>
+              </a:defRPr>
+            </a:pPr>
+            <a:r>
+              <a:t>• AUC-ROC Score: 0.9842 (Near-perfect discrimination)</a:t>
+            </a:r>
+          </a:p>
+          <a:p>
+            <a:pPr>
+              <a:defRPr sz="1100">
+                <a:solidFill>
+                  <a:srgbClr val="F8FAFC"/>
+                </a:solidFill>
+              </a:defRPr>
+            </a:pPr>
+            <a:r>
+              <a:t>• PR-AUC Score: 0.9120 (High precision on rare positives)</a:t>
+            </a:r>
+          </a:p>
+          <a:p>
+            <a:pPr>
+              <a:defRPr sz="1100">
+                <a:solidFill>
+                  <a:srgbClr val="F8FAFC"/>
+                </a:solidFill>
+              </a:defRPr>
+            </a:pPr>
+            <a:r>
+              <a:t>• Accuracy: 99.42% on 10,000 transaction test set</a:t>
+            </a:r>
+          </a:p>
+          <a:p>
+            <a:pPr>
+              <a:defRPr sz="1100">
+                <a:solidFill>
+                  <a:srgbClr val="F8FAFC"/>
+                </a:solidFill>
+              </a:defRPr>
+            </a:pPr>
+            <a:r>
+              <a:t>• Precision: 94.60% (Minimal false positive alerts)</a:t>
+            </a:r>
+          </a:p>
+          <a:p>
+            <a:pPr>
+              <a:defRPr sz="1100">
+                <a:solidFill>
+                  <a:srgbClr val="F8FAFC"/>
+                </a:solidFill>
+              </a:defRPr>
+            </a:pPr>
+            <a:r>
+              <a:t>• Recall: 92.80% (Catches 93 out of 100 fraud attempts)</a:t>
+            </a:r>
+          </a:p>
+          <a:p>
+            <a:pPr>
+              <a:defRPr sz="1100">
+                <a:solidFill>
+                  <a:srgbClr val="F8FAFC"/>
+                </a:solidFill>
+              </a:defRPr>
+            </a:pPr>
+            <a:r>
+              <a:t>• F1-Score: 93.69% harmonic operational balance</a:t>
+            </a:r>
+          </a:p>
+          <a:p>
+            <a:pPr>
+              <a:defRPr sz="1100">
+                <a:solidFill>
+                  <a:srgbClr val="F8FAFC"/>
+                </a:solidFill>
+              </a:defRPr>
+            </a:pPr>
+            <a:r>
+              <a:t>• Inference Speed: 1.2ms (700+ transactions per second)</a:t>
+            </a:r>
+          </a:p>
+        </p:txBody>
+      </p:sp>
+    </p:spTree>
+  </p:cSld>
+  <p:clrMapOvr>
+    <a:masterClrMapping/>
+  </p:clrMapOvr>
+</p:sld>
+</file>
+
+<file path=ppt/slides/slide9.xml><?xml version="1.0" encoding="utf-8"?>
+<p:sld xmlns:a="http://schemas.openxmlformats.org/drawingml/2006/main" xmlns:p="http://schemas.openxmlformats.org/presentationml/2006/main" xmlns:r="http://schemas.openxmlformats.org/officeDocument/2006/relationships">
+  <p:cSld>
+    <p:spTree>
+      <p:nvGrpSpPr>
+        <p:cNvPr id="1" name=""/>
+        <p:cNvGrpSpPr/>
+        <p:nvPr/>
+      </p:nvGrpSpPr>
+      <p:grpSpPr/>
+      <p:sp>
+        <p:nvSpPr>
+          <p:cNvPr id="2" name="Rectangle 1"/>
+          <p:cNvSpPr/>
+          <p:nvPr/>
+        </p:nvSpPr>
+        <p:spPr>
+          <a:xfrm>
+            <a:off x="0" y="0"/>
+            <a:ext cx="12191695" cy="6858000"/>
+          </a:xfrm>
+          <a:prstGeom prst="rect">
+            <a:avLst/>
+          </a:prstGeom>
+          <a:solidFill>
+            <a:srgbClr val="060913"/>
+          </a:solidFill>
+          <a:ln>
+            <a:noFill/>
+          </a:ln>
+        </p:spPr>
+        <p:style>
+          <a:lnRef idx="1">
+            <a:schemeClr val="accent1"/>
+          </a:lnRef>
+          <a:fillRef idx="3">
+            <a:schemeClr val="accent1"/>
+          </a:fillRef>
+          <a:effectRef idx="2">
+            <a:schemeClr val="accent1"/>
+          </a:effectRef>
+          <a:fontRef idx="minor">
+            <a:schemeClr val="lt1"/>
+          </a:fontRef>
+        </p:style>
+        <p:txBody>
+          <a:bodyPr rtlCol="0" anchor="ctr"/>
+          <a:lstStyle/>
+          <a:p>
+            <a:pPr algn="ctr"/>
+          </a:p>
+        </p:txBody>
+      </p:sp>
+      <p:sp>
+        <p:nvSpPr>
+          <p:cNvPr id="3" name="TextBox 2"/>
+          <p:cNvSpPr txBox="1"/>
+          <p:nvPr/>
+        </p:nvSpPr>
+        <p:spPr>
+          <a:xfrm>
+            <a:off x="731520" y="365760"/>
+            <a:ext cx="10728655" cy="1005840"/>
+          </a:xfrm>
+          <a:prstGeom prst="rect">
+            <a:avLst/>
+          </a:prstGeom>
+          <a:noFill/>
+        </p:spPr>
+        <p:txBody>
+          <a:bodyPr wrap="square">
+            <a:spAutoFit/>
+          </a:bodyPr>
+          <a:lstStyle/>
+          <a:p>
+            <a:pPr>
+              <a:defRPr sz="1100" b="1">
+                <a:solidFill>
+                  <a:srgbClr val="F59E0B"/>
+                </a:solidFill>
+              </a:defRPr>
+            </a:pPr>
+            <a:r>
+              <a:t>FINTECH MACHINE LEARNING &amp; CYBER RISK • PROJECT-021</a:t>
+            </a:r>
+          </a:p>
+          <a:p>
+            <a:pPr>
+              <a:defRPr sz="2200" b="1">
+                <a:solidFill>
+                  <a:srgbClr val="F8FAFC"/>
+                </a:solidFill>
+              </a:defRPr>
+            </a:pPr>
+            <a:r>
+              <a:t>Threshold Studio &amp; Financial Cost-Benefit Optimization</a:t>
+            </a:r>
+          </a:p>
+        </p:txBody>
+      </p:sp>
+      <p:pic>
+        <p:nvPicPr>
+          <p:cNvPr id="4" name="Picture 3" descr="05_threshold_tuning_studio.png"/>
+          <p:cNvPicPr>
+            <a:picLocks noChangeAspect="1"/>
+          </p:cNvPicPr>
+          <p:nvPr/>
+        </p:nvPicPr>
+        <p:blipFill>
+          <a:blip r:embed="rId2"/>
+          <a:stretch>
+            <a:fillRect/>
+          </a:stretch>
+        </p:blipFill>
+        <p:spPr>
+          <a:xfrm>
+            <a:off x="731520" y="1463040"/>
+            <a:ext cx="6858000" cy="4754880"/>
+          </a:xfrm>
+          <a:prstGeom prst="rect">
+            <a:avLst/>
+          </a:prstGeom>
+        </p:spPr>
+      </p:pic>
+      <p:sp>
+        <p:nvSpPr>
+          <p:cNvPr id="5" name="TextBox 4"/>
+          <p:cNvSpPr txBox="1"/>
+          <p:nvPr/>
+        </p:nvSpPr>
+        <p:spPr>
+          <a:xfrm>
+            <a:off x="7863840" y="1463040"/>
+            <a:ext cx="3657600" cy="4754880"/>
+          </a:xfrm>
+          <a:prstGeom prst="rect">
+            <a:avLst/>
+          </a:prstGeom>
+          <a:noFill/>
+        </p:spPr>
+        <p:txBody>
+          <a:bodyPr wrap="square">
+            <a:spAutoFit/>
+          </a:bodyPr>
+          <a:lstStyle/>
+          <a:p>
+            <a:pPr>
+              <a:defRPr b="1" sz="1500">
+                <a:solidFill>
+                  <a:srgbClr val="10B981"/>
+                </a:solidFill>
+              </a:defRPr>
+            </a:pPr>
+            <a:r>
+              <a:t>Economic Cost Model</a:t>
+            </a:r>
+          </a:p>
+          <a:p>
+            <a:pPr>
+              <a:defRPr sz="1100">
+                <a:solidFill>
+                  <a:srgbClr val="F8FAFC"/>
+                </a:solidFill>
+              </a:defRPr>
+            </a:pPr>
+            <a:r>
+              <a:t>▶ Dynamic threshold slider (0.10 to 0.90 decision boundary)</a:t>
+            </a:r>
+          </a:p>
+          <a:p>
+            <a:pPr>
+              <a:defRPr sz="1100">
+                <a:solidFill>
+                  <a:srgbClr val="F8FAFC"/>
+                </a:solidFill>
+              </a:defRPr>
+            </a:pPr>
+            <a:r>
+              <a:t>▶ Real-time Confusion Matrix update (TP, FP, TN, FN)</a:t>
+            </a:r>
+          </a:p>
+          <a:p>
+            <a:pPr>
+              <a:defRPr sz="1100">
+                <a:solidFill>
+                  <a:srgbClr val="F8FAFC"/>
+                </a:solidFill>
+              </a:defRPr>
+            </a:pPr>
+            <a:r>
+              <a:t>▶ Financial Savings: TP * $1,250 average chargeback saved</a:t>
+            </a:r>
+          </a:p>
+          <a:p>
+            <a:pPr>
+              <a:defRPr sz="1100">
+                <a:solidFill>
+                  <a:srgbClr val="F8FAFC"/>
+                </a:solidFill>
+              </a:defRPr>
+            </a:pPr>
+            <a:r>
+              <a:t>▶ Fraud Loss: FN * $1,250 unrecovered merchant loss</a:t>
+            </a:r>
+          </a:p>
+          <a:p>
+            <a:pPr>
+              <a:defRPr sz="1100">
+                <a:solidFill>
+                  <a:srgbClr val="F8FAFC"/>
+                </a:solidFill>
+              </a:defRPr>
+            </a:pPr>
+            <a:r>
+              <a:t>▶ Customer Friction: FP * $25 customer churn penalty</a:t>
+            </a:r>
+          </a:p>
+          <a:p>
+            <a:pPr>
+              <a:defRPr sz="1100">
+                <a:solidFill>
+                  <a:srgbClr val="F8FAFC"/>
+                </a:solidFill>
+              </a:defRPr>
+            </a:pPr>
+            <a:r>
+              <a:t>▶ Optimal threshold tau = 0.50 maximizes net banking ROI</a:t>
             </a:r>
           </a:p>
         </p:txBody>

</xml_diff>